<commit_message>
docs(slides): add "bring your own patient clusters" endotype-workflow slide
New slide (13) answering whether the map can characterise externally-defined
patient clusters: project any 3 clusters onto the map (AUCell module scoring +
per-cluster DEG mapped to species + MINERVA overlay — same pipeline, any
labels) and read back, per cluster, a module fingerprint, the lit-up
sub-circuits (mechanistic hypotheses), and active druggable hubs. No new
detection — characterisation of user-supplied clusters. Deck now 18 slides;
footers renumbered.

Co-Authored-By: Claude Opus 4.8 <noreply@anthropic.com>
</commit_message>
<xml_diff>
--- a/docs/SSc_MIM_presentation.pptx
+++ b/docs/SSc_MIM_presentation.pptx
@@ -22,6 +22,7 @@
     <p:sldId id="270" r:id="rId21"/>
     <p:sldId id="271" r:id="rId22"/>
     <p:sldId id="272" r:id="rId23"/>
+    <p:sldId id="273" r:id="rId24"/>
   </p:sldIdLst>
   <p:sldSz cx="12191695" cy="6858000" type="screen4x3"/>
   <p:notesSz cx="6858000" cy="9144000"/>
@@ -6316,7 +6317,7 @@
             <a:avLst/>
           </a:prstGeom>
           <a:solidFill>
-            <a:srgbClr val="2E8B9E"/>
+            <a:srgbClr val="E26D5A"/>
           </a:solidFill>
           <a:ln>
             <a:noFill/>
@@ -6378,11 +6379,11 @@
             <a:r>
               <a:rPr sz="1200" b="1" i="0">
                 <a:solidFill>
-                  <a:srgbClr val="2E8B9E"/>
-                </a:solidFill>
-                <a:latin typeface="Calibri"/>
-              </a:rPr>
-              <a:t>APPLICATION</a:t>
+                  <a:srgbClr val="E26D5A"/>
+                </a:solidFill>
+                <a:latin typeface="Calibri"/>
+              </a:rPr>
+              <a:t>ENDOTYPE WORKFLOW</a:t>
             </a:r>
           </a:p>
           <a:p>
@@ -6401,45 +6402,21 @@
                 </a:solidFill>
                 <a:latin typeface="Calibri"/>
               </a:rPr>
-              <a:t>A substrate for drug prioritisation</a:t>
-            </a:r>
-          </a:p>
-        </p:txBody>
-      </p:sp>
-      <p:pic>
-        <p:nvPicPr>
-          <p:cNvPr id="6" name="Picture 5" descr="F3_druggable_targets.png"/>
-          <p:cNvPicPr>
-            <a:picLocks noChangeAspect="1"/>
-          </p:cNvPicPr>
-          <p:nvPr/>
-        </p:nvPicPr>
-        <p:blipFill>
-          <a:blip r:embed="rId2"/>
-          <a:stretch>
-            <a:fillRect/>
-          </a:stretch>
-        </p:blipFill>
-        <p:spPr>
-          <a:xfrm>
-            <a:off x="457200" y="1417320"/>
-            <a:ext cx="6537960" cy="4754880"/>
-          </a:xfrm>
-          <a:prstGeom prst="rect">
-            <a:avLst/>
-          </a:prstGeom>
-        </p:spPr>
-      </p:pic>
-      <p:sp>
-        <p:nvSpPr>
-          <p:cNvPr id="7" name="TextBox 6"/>
+              <a:t>Bring your own patient clusters</a:t>
+            </a:r>
+          </a:p>
+        </p:txBody>
+      </p:sp>
+      <p:sp>
+        <p:nvSpPr>
+          <p:cNvPr id="6" name="TextBox 5"/>
           <p:cNvSpPr txBox="1"/>
           <p:nvPr/>
         </p:nvSpPr>
         <p:spPr>
           <a:xfrm>
-            <a:off x="7863840" y="1554480"/>
-            <a:ext cx="3931920" cy="4572000"/>
+            <a:off x="548640" y="1298448"/>
+            <a:ext cx="11064240" cy="640080"/>
           </a:xfrm>
           <a:prstGeom prst="rect">
             <a:avLst/>
@@ -6457,88 +6434,31 @@
                 <a:spcPts val="0"/>
               </a:spcBef>
               <a:spcAft>
-                <a:spcPts val="1000"/>
-              </a:spcAft>
-            </a:pPr>
-            <a:r>
-              <a:rPr sz="1350" b="0" i="0">
+                <a:spcPts val="600"/>
+              </a:spcAft>
+            </a:pPr>
+            <a:r>
+              <a:rPr sz="1550" b="0" i="1">
                 <a:solidFill>
                   <a:srgbClr val="223038"/>
                 </a:solidFill>
                 <a:latin typeface="Calibri"/>
               </a:rPr>
-              <a:t>Network hubs cross-referenced with DGIdb drug–target data.</a:t>
-            </a:r>
-          </a:p>
-          <a:p>
-            <a:pPr algn="l">
-              <a:spcBef>
-                <a:spcPts val="0"/>
-              </a:spcBef>
-              <a:spcAft>
-                <a:spcPts val="1000"/>
-              </a:spcAft>
-            </a:pPr>
-            <a:r>
-              <a:rPr sz="1350" b="0" i="0">
-                <a:solidFill>
-                  <a:srgbClr val="223038"/>
-                </a:solidFill>
-                <a:latin typeface="Calibri"/>
-              </a:rPr>
-              <a:t>Recovers targets already in SSc trials — tocilizumab (IL-6), nintedanib, romilkimab (IL-13), pamrevlumab (CTGF/CCN2), bosentan (endothelin).</a:t>
-            </a:r>
-          </a:p>
-          <a:p>
-            <a:pPr algn="l">
-              <a:spcBef>
-                <a:spcPts val="0"/>
-              </a:spcBef>
-              <a:spcAft>
-                <a:spcPts val="1000"/>
-              </a:spcAft>
-            </a:pPr>
-            <a:r>
-              <a:rPr sz="1350" b="0" i="0">
-                <a:solidFill>
-                  <a:srgbClr val="223038"/>
-                </a:solidFill>
-                <a:latin typeface="Calibri"/>
-              </a:rPr>
-              <a:t>Drug table recalibrated against real SSc clinical-trial outcomes.</a:t>
-            </a:r>
-          </a:p>
-          <a:p>
-            <a:pPr algn="l">
-              <a:spcBef>
-                <a:spcPts val="0"/>
-              </a:spcBef>
-              <a:spcAft>
-                <a:spcPts val="1000"/>
-              </a:spcAft>
-            </a:pPr>
-            <a:r>
-              <a:rPr sz="1350" b="0" i="0">
-                <a:solidFill>
-                  <a:srgbClr val="223038"/>
-                </a:solidFill>
-                <a:latin typeface="Calibri"/>
-              </a:rPr>
-              <a:t>Shows the map can rank and rationalise repurposing candidates.</a:t>
-            </a:r>
-          </a:p>
-        </p:txBody>
-      </p:sp>
-      <p:sp>
-        <p:nvSpPr>
-          <p:cNvPr id="8" name="TextBox 7"/>
+              <a:t>Have 3 patient clusters? Project them onto the map and read out what mechanistically separates them — same pipeline, your labels.</a:t>
+            </a:r>
+          </a:p>
+        </p:txBody>
+      </p:sp>
+      <p:sp>
+        <p:nvSpPr>
+          <p:cNvPr id="7" name="TextBox 6"/>
           <p:cNvSpPr txBox="1"/>
           <p:nvPr/>
         </p:nvSpPr>
         <p:spPr>
           <a:xfrm>
-            <a:off x="548640" y="6437376"/>
-            <a:ext cx="8229600" cy="365760"/>
+            <a:off x="548640" y="2057400"/>
+            <a:ext cx="2377440" cy="365760"/>
           </a:xfrm>
           <a:prstGeom prst="rect">
             <a:avLst/>
@@ -6560,6 +6480,883 @@
               </a:spcAft>
             </a:pPr>
             <a:r>
+              <a:rPr sz="1100" b="1" i="0">
+                <a:solidFill>
+                  <a:srgbClr val="6B7A82"/>
+                </a:solidFill>
+                <a:latin typeface="Calibri"/>
+              </a:rPr>
+              <a:t>YOUR CLUSTERS</a:t>
+            </a:r>
+          </a:p>
+        </p:txBody>
+      </p:sp>
+      <p:sp>
+        <p:nvSpPr>
+          <p:cNvPr id="8" name="Rounded Rectangle 7"/>
+          <p:cNvSpPr/>
+          <p:nvPr/>
+        </p:nvSpPr>
+        <p:spPr>
+          <a:xfrm>
+            <a:off x="548640" y="2377440"/>
+            <a:ext cx="2240280" cy="512064"/>
+          </a:xfrm>
+          <a:prstGeom prst="roundRect">
+            <a:avLst/>
+          </a:prstGeom>
+          <a:solidFill>
+            <a:srgbClr val="3A73B8"/>
+          </a:solidFill>
+          <a:ln>
+            <a:noFill/>
+          </a:ln>
+          <a:effectLst/>
+        </p:spPr>
+        <p:style>
+          <a:lnRef idx="1">
+            <a:schemeClr val="accent1"/>
+          </a:lnRef>
+          <a:fillRef idx="3">
+            <a:schemeClr val="accent1"/>
+          </a:fillRef>
+          <a:effectRef idx="2">
+            <a:schemeClr val="accent1"/>
+          </a:effectRef>
+          <a:fontRef idx="minor">
+            <a:schemeClr val="lt1"/>
+          </a:fontRef>
+        </p:style>
+        <p:txBody>
+          <a:bodyPr rtlCol="0" anchor="ctr"/>
+          <a:lstStyle/>
+          <a:p>
+            <a:pPr algn="ctr">
+              <a:spcBef>
+                <a:spcPts val="0"/>
+              </a:spcBef>
+              <a:spcAft>
+                <a:spcPts val="600"/>
+              </a:spcAft>
+            </a:pPr>
+            <a:r>
+              <a:rPr sz="1500" b="1" i="0">
+                <a:solidFill>
+                  <a:srgbClr val="FFFFFF"/>
+                </a:solidFill>
+                <a:latin typeface="Calibri"/>
+              </a:rPr>
+              <a:t>Cluster 1</a:t>
+            </a:r>
+          </a:p>
+        </p:txBody>
+      </p:sp>
+      <p:sp>
+        <p:nvSpPr>
+          <p:cNvPr id="9" name="Rounded Rectangle 8"/>
+          <p:cNvSpPr/>
+          <p:nvPr/>
+        </p:nvSpPr>
+        <p:spPr>
+          <a:xfrm>
+            <a:off x="548640" y="2980944"/>
+            <a:ext cx="2240280" cy="512064"/>
+          </a:xfrm>
+          <a:prstGeom prst="roundRect">
+            <a:avLst/>
+          </a:prstGeom>
+          <a:solidFill>
+            <a:srgbClr val="3F9E8C"/>
+          </a:solidFill>
+          <a:ln>
+            <a:noFill/>
+          </a:ln>
+          <a:effectLst/>
+        </p:spPr>
+        <p:style>
+          <a:lnRef idx="1">
+            <a:schemeClr val="accent1"/>
+          </a:lnRef>
+          <a:fillRef idx="3">
+            <a:schemeClr val="accent1"/>
+          </a:fillRef>
+          <a:effectRef idx="2">
+            <a:schemeClr val="accent1"/>
+          </a:effectRef>
+          <a:fontRef idx="minor">
+            <a:schemeClr val="lt1"/>
+          </a:fontRef>
+        </p:style>
+        <p:txBody>
+          <a:bodyPr rtlCol="0" anchor="ctr"/>
+          <a:lstStyle/>
+          <a:p>
+            <a:pPr algn="ctr">
+              <a:spcBef>
+                <a:spcPts val="0"/>
+              </a:spcBef>
+              <a:spcAft>
+                <a:spcPts val="600"/>
+              </a:spcAft>
+            </a:pPr>
+            <a:r>
+              <a:rPr sz="1500" b="1" i="0">
+                <a:solidFill>
+                  <a:srgbClr val="FFFFFF"/>
+                </a:solidFill>
+                <a:latin typeface="Calibri"/>
+              </a:rPr>
+              <a:t>Cluster 2</a:t>
+            </a:r>
+          </a:p>
+        </p:txBody>
+      </p:sp>
+      <p:sp>
+        <p:nvSpPr>
+          <p:cNvPr id="10" name="Rounded Rectangle 9"/>
+          <p:cNvSpPr/>
+          <p:nvPr/>
+        </p:nvSpPr>
+        <p:spPr>
+          <a:xfrm>
+            <a:off x="548640" y="3584448"/>
+            <a:ext cx="2240280" cy="512064"/>
+          </a:xfrm>
+          <a:prstGeom prst="roundRect">
+            <a:avLst/>
+          </a:prstGeom>
+          <a:solidFill>
+            <a:srgbClr val="E26D5A"/>
+          </a:solidFill>
+          <a:ln>
+            <a:noFill/>
+          </a:ln>
+          <a:effectLst/>
+        </p:spPr>
+        <p:style>
+          <a:lnRef idx="1">
+            <a:schemeClr val="accent1"/>
+          </a:lnRef>
+          <a:fillRef idx="3">
+            <a:schemeClr val="accent1"/>
+          </a:fillRef>
+          <a:effectRef idx="2">
+            <a:schemeClr val="accent1"/>
+          </a:effectRef>
+          <a:fontRef idx="minor">
+            <a:schemeClr val="lt1"/>
+          </a:fontRef>
+        </p:style>
+        <p:txBody>
+          <a:bodyPr rtlCol="0" anchor="ctr"/>
+          <a:lstStyle/>
+          <a:p>
+            <a:pPr algn="ctr">
+              <a:spcBef>
+                <a:spcPts val="0"/>
+              </a:spcBef>
+              <a:spcAft>
+                <a:spcPts val="600"/>
+              </a:spcAft>
+            </a:pPr>
+            <a:r>
+              <a:rPr sz="1500" b="1" i="0">
+                <a:solidFill>
+                  <a:srgbClr val="FFFFFF"/>
+                </a:solidFill>
+                <a:latin typeface="Calibri"/>
+              </a:rPr>
+              <a:t>Cluster 3</a:t>
+            </a:r>
+          </a:p>
+        </p:txBody>
+      </p:sp>
+      <p:sp>
+        <p:nvSpPr>
+          <p:cNvPr id="11" name="TextBox 10"/>
+          <p:cNvSpPr txBox="1"/>
+          <p:nvPr/>
+        </p:nvSpPr>
+        <p:spPr>
+          <a:xfrm>
+            <a:off x="2834640" y="2971800"/>
+            <a:ext cx="640080" cy="640080"/>
+          </a:xfrm>
+          <a:prstGeom prst="rect">
+            <a:avLst/>
+          </a:prstGeom>
+          <a:noFill/>
+        </p:spPr>
+        <p:txBody>
+          <a:bodyPr wrap="square">
+            <a:spAutoFit/>
+          </a:bodyPr>
+          <a:lstStyle/>
+          <a:p>
+            <a:pPr algn="ctr">
+              <a:spcBef>
+                <a:spcPts val="0"/>
+              </a:spcBef>
+              <a:spcAft>
+                <a:spcPts val="600"/>
+              </a:spcAft>
+            </a:pPr>
+            <a:r>
+              <a:rPr sz="2600" b="1" i="0">
+                <a:solidFill>
+                  <a:srgbClr val="E26D5A"/>
+                </a:solidFill>
+                <a:latin typeface="Calibri"/>
+              </a:rPr>
+              <a:t>→</a:t>
+            </a:r>
+          </a:p>
+        </p:txBody>
+      </p:sp>
+      <p:sp>
+        <p:nvSpPr>
+          <p:cNvPr id="12" name="Rectangle 11"/>
+          <p:cNvSpPr/>
+          <p:nvPr/>
+        </p:nvSpPr>
+        <p:spPr>
+          <a:xfrm>
+            <a:off x="3520440" y="2331720"/>
+            <a:ext cx="8092440" cy="1783080"/>
+          </a:xfrm>
+          <a:prstGeom prst="rect">
+            <a:avLst/>
+          </a:prstGeom>
+          <a:solidFill>
+            <a:srgbClr val="142C3A"/>
+          </a:solidFill>
+          <a:ln>
+            <a:noFill/>
+          </a:ln>
+          <a:effectLst/>
+        </p:spPr>
+        <p:style>
+          <a:lnRef idx="1">
+            <a:schemeClr val="accent1"/>
+          </a:lnRef>
+          <a:fillRef idx="3">
+            <a:schemeClr val="accent1"/>
+          </a:fillRef>
+          <a:effectRef idx="2">
+            <a:schemeClr val="accent1"/>
+          </a:effectRef>
+          <a:fontRef idx="minor">
+            <a:schemeClr val="lt1"/>
+          </a:fontRef>
+        </p:style>
+        <p:txBody>
+          <a:bodyPr rtlCol="0" anchor="ctr"/>
+          <a:lstStyle/>
+          <a:p>
+            <a:pPr algn="ctr"/>
+          </a:p>
+        </p:txBody>
+      </p:sp>
+      <p:sp>
+        <p:nvSpPr>
+          <p:cNvPr id="13" name="TextBox 12"/>
+          <p:cNvSpPr txBox="1"/>
+          <p:nvPr/>
+        </p:nvSpPr>
+        <p:spPr>
+          <a:xfrm>
+            <a:off x="3794760" y="2487168"/>
+            <a:ext cx="7589520" cy="1554480"/>
+          </a:xfrm>
+          <a:prstGeom prst="rect">
+            <a:avLst/>
+          </a:prstGeom>
+          <a:noFill/>
+        </p:spPr>
+        <p:txBody>
+          <a:bodyPr wrap="square">
+            <a:spAutoFit/>
+          </a:bodyPr>
+          <a:lstStyle/>
+          <a:p>
+            <a:pPr algn="l">
+              <a:spcBef>
+                <a:spcPts val="0"/>
+              </a:spcBef>
+              <a:spcAft>
+                <a:spcPts val="400"/>
+              </a:spcAft>
+            </a:pPr>
+            <a:r>
+              <a:rPr sz="1250" b="0" i="0">
+                <a:solidFill>
+                  <a:srgbClr val="DDE7EA"/>
+                </a:solidFill>
+                <a:latin typeface="Calibri"/>
+              </a:rPr>
+              <a:t>AUCell — score each cluster on the 4 modules (M1/M2/M3/M4 + Tier-1).</a:t>
+            </a:r>
+          </a:p>
+          <a:p>
+            <a:pPr algn="l">
+              <a:spcBef>
+                <a:spcPts val="0"/>
+              </a:spcBef>
+              <a:spcAft>
+                <a:spcPts val="400"/>
+              </a:spcAft>
+            </a:pPr>
+            <a:r>
+              <a:rPr sz="1250" b="0" i="0">
+                <a:solidFill>
+                  <a:srgbClr val="DDE7EA"/>
+                </a:solidFill>
+                <a:latin typeface="Calibri"/>
+              </a:rPr>
+              <a:t>Per-cluster differential expression mapped onto map species → which reactions light up.</a:t>
+            </a:r>
+          </a:p>
+          <a:p>
+            <a:pPr algn="l">
+              <a:spcBef>
+                <a:spcPts val="0"/>
+              </a:spcBef>
+              <a:spcAft>
+                <a:spcPts val="400"/>
+              </a:spcAft>
+            </a:pPr>
+            <a:r>
+              <a:rPr sz="1250" b="0" i="0">
+                <a:solidFill>
+                  <a:srgbClr val="DDE7EA"/>
+                </a:solidFill>
+                <a:latin typeface="Calibri"/>
+              </a:rPr>
+              <a:t>MINERVA overlay — colour the map by each cluster (any cluster label, no new method).</a:t>
+            </a:r>
+          </a:p>
+        </p:txBody>
+      </p:sp>
+      <p:sp>
+        <p:nvSpPr>
+          <p:cNvPr id="14" name="TextBox 13"/>
+          <p:cNvSpPr txBox="1"/>
+          <p:nvPr/>
+        </p:nvSpPr>
+        <p:spPr>
+          <a:xfrm>
+            <a:off x="548640" y="4480560"/>
+            <a:ext cx="11064240" cy="365760"/>
+          </a:xfrm>
+          <a:prstGeom prst="rect">
+            <a:avLst/>
+          </a:prstGeom>
+          <a:noFill/>
+        </p:spPr>
+        <p:txBody>
+          <a:bodyPr wrap="square">
+            <a:spAutoFit/>
+          </a:bodyPr>
+          <a:lstStyle/>
+          <a:p>
+            <a:pPr algn="l">
+              <a:spcBef>
+                <a:spcPts val="0"/>
+              </a:spcBef>
+              <a:spcAft>
+                <a:spcPts val="600"/>
+              </a:spcAft>
+            </a:pPr>
+            <a:r>
+              <a:rPr sz="1100" b="1" i="0">
+                <a:solidFill>
+                  <a:srgbClr val="6B7A82"/>
+                </a:solidFill>
+                <a:latin typeface="Calibri"/>
+              </a:rPr>
+              <a:t>WHAT YOU GET BACK — per cluster</a:t>
+            </a:r>
+          </a:p>
+        </p:txBody>
+      </p:sp>
+      <p:sp>
+        <p:nvSpPr>
+          <p:cNvPr id="15" name="Rectangle 14"/>
+          <p:cNvSpPr/>
+          <p:nvPr/>
+        </p:nvSpPr>
+        <p:spPr>
+          <a:xfrm>
+            <a:off x="548640" y="4828032"/>
+            <a:ext cx="3611880" cy="1371600"/>
+          </a:xfrm>
+          <a:prstGeom prst="rect">
+            <a:avLst/>
+          </a:prstGeom>
+          <a:solidFill>
+            <a:srgbClr val="FFFFFF"/>
+          </a:solidFill>
+          <a:ln>
+            <a:noFill/>
+          </a:ln>
+          <a:effectLst/>
+        </p:spPr>
+        <p:style>
+          <a:lnRef idx="1">
+            <a:schemeClr val="accent1"/>
+          </a:lnRef>
+          <a:fillRef idx="3">
+            <a:schemeClr val="accent1"/>
+          </a:fillRef>
+          <a:effectRef idx="2">
+            <a:schemeClr val="accent1"/>
+          </a:effectRef>
+          <a:fontRef idx="minor">
+            <a:schemeClr val="lt1"/>
+          </a:fontRef>
+        </p:style>
+        <p:txBody>
+          <a:bodyPr rtlCol="0" anchor="ctr"/>
+          <a:lstStyle/>
+          <a:p>
+            <a:pPr algn="ctr"/>
+          </a:p>
+        </p:txBody>
+      </p:sp>
+      <p:sp>
+        <p:nvSpPr>
+          <p:cNvPr id="16" name="Rectangle 15"/>
+          <p:cNvSpPr/>
+          <p:nvPr/>
+        </p:nvSpPr>
+        <p:spPr>
+          <a:xfrm>
+            <a:off x="548640" y="4828032"/>
+            <a:ext cx="3611880" cy="73152"/>
+          </a:xfrm>
+          <a:prstGeom prst="rect">
+            <a:avLst/>
+          </a:prstGeom>
+          <a:solidFill>
+            <a:srgbClr val="3A73B8"/>
+          </a:solidFill>
+          <a:ln>
+            <a:noFill/>
+          </a:ln>
+          <a:effectLst/>
+        </p:spPr>
+        <p:style>
+          <a:lnRef idx="1">
+            <a:schemeClr val="accent1"/>
+          </a:lnRef>
+          <a:fillRef idx="3">
+            <a:schemeClr val="accent1"/>
+          </a:fillRef>
+          <a:effectRef idx="2">
+            <a:schemeClr val="accent1"/>
+          </a:effectRef>
+          <a:fontRef idx="minor">
+            <a:schemeClr val="lt1"/>
+          </a:fontRef>
+        </p:style>
+        <p:txBody>
+          <a:bodyPr rtlCol="0" anchor="ctr"/>
+          <a:lstStyle/>
+          <a:p>
+            <a:pPr algn="ctr"/>
+          </a:p>
+        </p:txBody>
+      </p:sp>
+      <p:sp>
+        <p:nvSpPr>
+          <p:cNvPr id="17" name="TextBox 16"/>
+          <p:cNvSpPr txBox="1"/>
+          <p:nvPr/>
+        </p:nvSpPr>
+        <p:spPr>
+          <a:xfrm>
+            <a:off x="749808" y="4956048"/>
+            <a:ext cx="3246120" cy="1188720"/>
+          </a:xfrm>
+          <a:prstGeom prst="rect">
+            <a:avLst/>
+          </a:prstGeom>
+          <a:noFill/>
+        </p:spPr>
+        <p:txBody>
+          <a:bodyPr wrap="square">
+            <a:spAutoFit/>
+          </a:bodyPr>
+          <a:lstStyle/>
+          <a:p>
+            <a:pPr algn="l">
+              <a:spcBef>
+                <a:spcPts val="0"/>
+              </a:spcBef>
+              <a:spcAft>
+                <a:spcPts val="500"/>
+              </a:spcAft>
+            </a:pPr>
+            <a:r>
+              <a:rPr sz="1450" b="1" i="0">
+                <a:solidFill>
+                  <a:srgbClr val="3A73B8"/>
+                </a:solidFill>
+                <a:latin typeface="Calibri"/>
+              </a:rPr>
+              <a:t>Module fingerprint</a:t>
+            </a:r>
+          </a:p>
+          <a:p>
+            <a:pPr algn="l">
+              <a:spcBef>
+                <a:spcPts val="0"/>
+              </a:spcBef>
+              <a:spcAft>
+                <a:spcPts val="600"/>
+              </a:spcAft>
+            </a:pPr>
+            <a:r>
+              <a:rPr sz="1200" b="0" i="0">
+                <a:solidFill>
+                  <a:srgbClr val="223038"/>
+                </a:solidFill>
+                <a:latin typeface="Calibri"/>
+              </a:rPr>
+              <a:t>A 4-module activation vector per cluster — e.g. cluster 2 IFN-high, cluster 3 fibrosis-dominant.</a:t>
+            </a:r>
+          </a:p>
+        </p:txBody>
+      </p:sp>
+      <p:sp>
+        <p:nvSpPr>
+          <p:cNvPr id="18" name="Rectangle 17"/>
+          <p:cNvSpPr/>
+          <p:nvPr/>
+        </p:nvSpPr>
+        <p:spPr>
+          <a:xfrm>
+            <a:off x="4315968" y="4828032"/>
+            <a:ext cx="3611880" cy="1371600"/>
+          </a:xfrm>
+          <a:prstGeom prst="rect">
+            <a:avLst/>
+          </a:prstGeom>
+          <a:solidFill>
+            <a:srgbClr val="FFFFFF"/>
+          </a:solidFill>
+          <a:ln>
+            <a:noFill/>
+          </a:ln>
+          <a:effectLst/>
+        </p:spPr>
+        <p:style>
+          <a:lnRef idx="1">
+            <a:schemeClr val="accent1"/>
+          </a:lnRef>
+          <a:fillRef idx="3">
+            <a:schemeClr val="accent1"/>
+          </a:fillRef>
+          <a:effectRef idx="2">
+            <a:schemeClr val="accent1"/>
+          </a:effectRef>
+          <a:fontRef idx="minor">
+            <a:schemeClr val="lt1"/>
+          </a:fontRef>
+        </p:style>
+        <p:txBody>
+          <a:bodyPr rtlCol="0" anchor="ctr"/>
+          <a:lstStyle/>
+          <a:p>
+            <a:pPr algn="ctr"/>
+          </a:p>
+        </p:txBody>
+      </p:sp>
+      <p:sp>
+        <p:nvSpPr>
+          <p:cNvPr id="19" name="Rectangle 18"/>
+          <p:cNvSpPr/>
+          <p:nvPr/>
+        </p:nvSpPr>
+        <p:spPr>
+          <a:xfrm>
+            <a:off x="4315968" y="4828032"/>
+            <a:ext cx="3611880" cy="73152"/>
+          </a:xfrm>
+          <a:prstGeom prst="rect">
+            <a:avLst/>
+          </a:prstGeom>
+          <a:solidFill>
+            <a:srgbClr val="E26D5A"/>
+          </a:solidFill>
+          <a:ln>
+            <a:noFill/>
+          </a:ln>
+          <a:effectLst/>
+        </p:spPr>
+        <p:style>
+          <a:lnRef idx="1">
+            <a:schemeClr val="accent1"/>
+          </a:lnRef>
+          <a:fillRef idx="3">
+            <a:schemeClr val="accent1"/>
+          </a:fillRef>
+          <a:effectRef idx="2">
+            <a:schemeClr val="accent1"/>
+          </a:effectRef>
+          <a:fontRef idx="minor">
+            <a:schemeClr val="lt1"/>
+          </a:fontRef>
+        </p:style>
+        <p:txBody>
+          <a:bodyPr rtlCol="0" anchor="ctr"/>
+          <a:lstStyle/>
+          <a:p>
+            <a:pPr algn="ctr"/>
+          </a:p>
+        </p:txBody>
+      </p:sp>
+      <p:sp>
+        <p:nvSpPr>
+          <p:cNvPr id="20" name="TextBox 19"/>
+          <p:cNvSpPr txBox="1"/>
+          <p:nvPr/>
+        </p:nvSpPr>
+        <p:spPr>
+          <a:xfrm>
+            <a:off x="4517136" y="4956048"/>
+            <a:ext cx="3246120" cy="1188720"/>
+          </a:xfrm>
+          <a:prstGeom prst="rect">
+            <a:avLst/>
+          </a:prstGeom>
+          <a:noFill/>
+        </p:spPr>
+        <p:txBody>
+          <a:bodyPr wrap="square">
+            <a:spAutoFit/>
+          </a:bodyPr>
+          <a:lstStyle/>
+          <a:p>
+            <a:pPr algn="l">
+              <a:spcBef>
+                <a:spcPts val="0"/>
+              </a:spcBef>
+              <a:spcAft>
+                <a:spcPts val="500"/>
+              </a:spcAft>
+            </a:pPr>
+            <a:r>
+              <a:rPr sz="1450" b="1" i="0">
+                <a:solidFill>
+                  <a:srgbClr val="E26D5A"/>
+                </a:solidFill>
+                <a:latin typeface="Calibri"/>
+              </a:rPr>
+              <a:t>Mechanistic hypotheses</a:t>
+            </a:r>
+          </a:p>
+          <a:p>
+            <a:pPr algn="l">
+              <a:spcBef>
+                <a:spcPts val="0"/>
+              </a:spcBef>
+              <a:spcAft>
+                <a:spcPts val="600"/>
+              </a:spcAft>
+            </a:pPr>
+            <a:r>
+              <a:rPr sz="1200" b="0" i="0">
+                <a:solidFill>
+                  <a:srgbClr val="223038"/>
+                </a:solidFill>
+                <a:latin typeface="Calibri"/>
+              </a:rPr>
+              <a:t>The lit-up sub-circuits that distinguish each cluster — e.g. STING→IRF3 vs TGF-β→SMAD3→collagen.</a:t>
+            </a:r>
+          </a:p>
+        </p:txBody>
+      </p:sp>
+      <p:sp>
+        <p:nvSpPr>
+          <p:cNvPr id="21" name="Rectangle 20"/>
+          <p:cNvSpPr/>
+          <p:nvPr/>
+        </p:nvSpPr>
+        <p:spPr>
+          <a:xfrm>
+            <a:off x="8083296" y="4828032"/>
+            <a:ext cx="3611880" cy="1371600"/>
+          </a:xfrm>
+          <a:prstGeom prst="rect">
+            <a:avLst/>
+          </a:prstGeom>
+          <a:solidFill>
+            <a:srgbClr val="FFFFFF"/>
+          </a:solidFill>
+          <a:ln>
+            <a:noFill/>
+          </a:ln>
+          <a:effectLst/>
+        </p:spPr>
+        <p:style>
+          <a:lnRef idx="1">
+            <a:schemeClr val="accent1"/>
+          </a:lnRef>
+          <a:fillRef idx="3">
+            <a:schemeClr val="accent1"/>
+          </a:fillRef>
+          <a:effectRef idx="2">
+            <a:schemeClr val="accent1"/>
+          </a:effectRef>
+          <a:fontRef idx="minor">
+            <a:schemeClr val="lt1"/>
+          </a:fontRef>
+        </p:style>
+        <p:txBody>
+          <a:bodyPr rtlCol="0" anchor="ctr"/>
+          <a:lstStyle/>
+          <a:p>
+            <a:pPr algn="ctr"/>
+          </a:p>
+        </p:txBody>
+      </p:sp>
+      <p:sp>
+        <p:nvSpPr>
+          <p:cNvPr id="22" name="Rectangle 21"/>
+          <p:cNvSpPr/>
+          <p:nvPr/>
+        </p:nvSpPr>
+        <p:spPr>
+          <a:xfrm>
+            <a:off x="8083296" y="4828032"/>
+            <a:ext cx="3611880" cy="73152"/>
+          </a:xfrm>
+          <a:prstGeom prst="rect">
+            <a:avLst/>
+          </a:prstGeom>
+          <a:solidFill>
+            <a:srgbClr val="3F9E8C"/>
+          </a:solidFill>
+          <a:ln>
+            <a:noFill/>
+          </a:ln>
+          <a:effectLst/>
+        </p:spPr>
+        <p:style>
+          <a:lnRef idx="1">
+            <a:schemeClr val="accent1"/>
+          </a:lnRef>
+          <a:fillRef idx="3">
+            <a:schemeClr val="accent1"/>
+          </a:fillRef>
+          <a:effectRef idx="2">
+            <a:schemeClr val="accent1"/>
+          </a:effectRef>
+          <a:fontRef idx="minor">
+            <a:schemeClr val="lt1"/>
+          </a:fontRef>
+        </p:style>
+        <p:txBody>
+          <a:bodyPr rtlCol="0" anchor="ctr"/>
+          <a:lstStyle/>
+          <a:p>
+            <a:pPr algn="ctr"/>
+          </a:p>
+        </p:txBody>
+      </p:sp>
+      <p:sp>
+        <p:nvSpPr>
+          <p:cNvPr id="23" name="TextBox 22"/>
+          <p:cNvSpPr txBox="1"/>
+          <p:nvPr/>
+        </p:nvSpPr>
+        <p:spPr>
+          <a:xfrm>
+            <a:off x="8284464" y="4956048"/>
+            <a:ext cx="3246120" cy="1188720"/>
+          </a:xfrm>
+          <a:prstGeom prst="rect">
+            <a:avLst/>
+          </a:prstGeom>
+          <a:noFill/>
+        </p:spPr>
+        <p:txBody>
+          <a:bodyPr wrap="square">
+            <a:spAutoFit/>
+          </a:bodyPr>
+          <a:lstStyle/>
+          <a:p>
+            <a:pPr algn="l">
+              <a:spcBef>
+                <a:spcPts val="0"/>
+              </a:spcBef>
+              <a:spcAft>
+                <a:spcPts val="500"/>
+              </a:spcAft>
+            </a:pPr>
+            <a:r>
+              <a:rPr sz="1450" b="1" i="0">
+                <a:solidFill>
+                  <a:srgbClr val="3F9E8C"/>
+                </a:solidFill>
+                <a:latin typeface="Calibri"/>
+              </a:rPr>
+              <a:t>Candidate targets</a:t>
+            </a:r>
+          </a:p>
+          <a:p>
+            <a:pPr algn="l">
+              <a:spcBef>
+                <a:spcPts val="0"/>
+              </a:spcBef>
+              <a:spcAft>
+                <a:spcPts val="600"/>
+              </a:spcAft>
+            </a:pPr>
+            <a:r>
+              <a:rPr sz="1200" b="0" i="0">
+                <a:solidFill>
+                  <a:srgbClr val="223038"/>
+                </a:solidFill>
+                <a:latin typeface="Calibri"/>
+              </a:rPr>
+              <a:t>Active druggable hubs per cluster → a cluster-matched therapy hypothesis to test.</a:t>
+            </a:r>
+          </a:p>
+        </p:txBody>
+      </p:sp>
+      <p:sp>
+        <p:nvSpPr>
+          <p:cNvPr id="24" name="TextBox 23"/>
+          <p:cNvSpPr txBox="1"/>
+          <p:nvPr/>
+        </p:nvSpPr>
+        <p:spPr>
+          <a:xfrm>
+            <a:off x="548640" y="6437376"/>
+            <a:ext cx="8229600" cy="365760"/>
+          </a:xfrm>
+          <a:prstGeom prst="rect">
+            <a:avLst/>
+          </a:prstGeom>
+          <a:noFill/>
+        </p:spPr>
+        <p:txBody>
+          <a:bodyPr wrap="square">
+            <a:spAutoFit/>
+          </a:bodyPr>
+          <a:lstStyle/>
+          <a:p>
+            <a:pPr algn="l">
+              <a:spcBef>
+                <a:spcPts val="0"/>
+              </a:spcBef>
+              <a:spcAft>
+                <a:spcPts val="600"/>
+              </a:spcAft>
+            </a:pPr>
+            <a:r>
               <a:rPr sz="900" b="0" i="0">
                 <a:solidFill>
                   <a:srgbClr val="6B7A82"/>
@@ -6573,7 +7370,7 @@
       </p:sp>
       <p:sp>
         <p:nvSpPr>
-          <p:cNvPr id="9" name="TextBox 8"/>
+          <p:cNvPr id="25" name="TextBox 24"/>
           <p:cNvSpPr txBox="1"/>
           <p:nvPr/>
         </p:nvSpPr>
@@ -6734,602 +7531,6 @@
             <a:avLst/>
           </a:prstGeom>
           <a:solidFill>
-            <a:srgbClr val="E26D5A"/>
-          </a:solidFill>
-          <a:ln>
-            <a:noFill/>
-          </a:ln>
-          <a:effectLst/>
-        </p:spPr>
-        <p:style>
-          <a:lnRef idx="1">
-            <a:schemeClr val="accent1"/>
-          </a:lnRef>
-          <a:fillRef idx="3">
-            <a:schemeClr val="accent1"/>
-          </a:fillRef>
-          <a:effectRef idx="2">
-            <a:schemeClr val="accent1"/>
-          </a:effectRef>
-          <a:fontRef idx="minor">
-            <a:schemeClr val="lt1"/>
-          </a:fontRef>
-        </p:style>
-        <p:txBody>
-          <a:bodyPr rtlCol="0" anchor="ctr"/>
-          <a:lstStyle/>
-          <a:p>
-            <a:pPr algn="ctr"/>
-          </a:p>
-        </p:txBody>
-      </p:sp>
-      <p:sp>
-        <p:nvSpPr>
-          <p:cNvPr id="5" name="TextBox 4"/>
-          <p:cNvSpPr txBox="1"/>
-          <p:nvPr/>
-        </p:nvSpPr>
-        <p:spPr>
-          <a:xfrm>
-            <a:off x="548640" y="109728"/>
-            <a:ext cx="11155680" cy="914400"/>
-          </a:xfrm>
-          <a:prstGeom prst="rect">
-            <a:avLst/>
-          </a:prstGeom>
-          <a:noFill/>
-        </p:spPr>
-        <p:txBody>
-          <a:bodyPr wrap="square">
-            <a:spAutoFit/>
-          </a:bodyPr>
-          <a:lstStyle/>
-          <a:p>
-            <a:pPr algn="l">
-              <a:spcBef>
-                <a:spcPts val="0"/>
-              </a:spcBef>
-              <a:spcAft>
-                <a:spcPts val="600"/>
-              </a:spcAft>
-            </a:pPr>
-            <a:r>
-              <a:rPr sz="1200" b="1" i="0">
-                <a:solidFill>
-                  <a:srgbClr val="E26D5A"/>
-                </a:solidFill>
-                <a:latin typeface="Calibri"/>
-              </a:rPr>
-              <a:t>QUALITY CONTROL</a:t>
-            </a:r>
-          </a:p>
-          <a:p>
-            <a:pPr algn="l">
-              <a:spcBef>
-                <a:spcPts val="100"/>
-              </a:spcBef>
-              <a:spcAft>
-                <a:spcPts val="600"/>
-              </a:spcAft>
-            </a:pPr>
-            <a:r>
-              <a:rPr sz="2500" b="1" i="0">
-                <a:solidFill>
-                  <a:srgbClr val="FFFFFF"/>
-                </a:solidFill>
-                <a:latin typeface="Calibri"/>
-              </a:rPr>
-              <a:t>Independent verification of every interaction</a:t>
-            </a:r>
-          </a:p>
-        </p:txBody>
-      </p:sp>
-      <p:sp>
-        <p:nvSpPr>
-          <p:cNvPr id="6" name="Rectangle 5"/>
-          <p:cNvSpPr/>
-          <p:nvPr/>
-        </p:nvSpPr>
-        <p:spPr>
-          <a:xfrm>
-            <a:off x="548640" y="1417320"/>
-            <a:ext cx="2743200" cy="1554480"/>
-          </a:xfrm>
-          <a:prstGeom prst="rect">
-            <a:avLst/>
-          </a:prstGeom>
-          <a:solidFill>
-            <a:srgbClr val="FFFFFF"/>
-          </a:solidFill>
-          <a:ln>
-            <a:noFill/>
-          </a:ln>
-          <a:effectLst/>
-        </p:spPr>
-        <p:style>
-          <a:lnRef idx="1">
-            <a:schemeClr val="accent1"/>
-          </a:lnRef>
-          <a:fillRef idx="3">
-            <a:schemeClr val="accent1"/>
-          </a:fillRef>
-          <a:effectRef idx="2">
-            <a:schemeClr val="accent1"/>
-          </a:effectRef>
-          <a:fontRef idx="minor">
-            <a:schemeClr val="lt1"/>
-          </a:fontRef>
-        </p:style>
-        <p:txBody>
-          <a:bodyPr rtlCol="0" anchor="ctr"/>
-          <a:lstStyle/>
-          <a:p>
-            <a:pPr algn="ctr"/>
-          </a:p>
-        </p:txBody>
-      </p:sp>
-      <p:sp>
-        <p:nvSpPr>
-          <p:cNvPr id="7" name="Rectangle 6"/>
-          <p:cNvSpPr/>
-          <p:nvPr/>
-        </p:nvSpPr>
-        <p:spPr>
-          <a:xfrm>
-            <a:off x="548640" y="1417320"/>
-            <a:ext cx="91440" cy="1554480"/>
-          </a:xfrm>
-          <a:prstGeom prst="rect">
-            <a:avLst/>
-          </a:prstGeom>
-          <a:solidFill>
-            <a:srgbClr val="142C3A"/>
-          </a:solidFill>
-          <a:ln>
-            <a:noFill/>
-          </a:ln>
-          <a:effectLst/>
-        </p:spPr>
-        <p:style>
-          <a:lnRef idx="1">
-            <a:schemeClr val="accent1"/>
-          </a:lnRef>
-          <a:fillRef idx="3">
-            <a:schemeClr val="accent1"/>
-          </a:fillRef>
-          <a:effectRef idx="2">
-            <a:schemeClr val="accent1"/>
-          </a:effectRef>
-          <a:fontRef idx="minor">
-            <a:schemeClr val="lt1"/>
-          </a:fontRef>
-        </p:style>
-        <p:txBody>
-          <a:bodyPr rtlCol="0" anchor="ctr"/>
-          <a:lstStyle/>
-          <a:p>
-            <a:pPr algn="ctr"/>
-          </a:p>
-        </p:txBody>
-      </p:sp>
-      <p:sp>
-        <p:nvSpPr>
-          <p:cNvPr id="8" name="TextBox 7"/>
-          <p:cNvSpPr txBox="1"/>
-          <p:nvPr/>
-        </p:nvSpPr>
-        <p:spPr>
-          <a:xfrm>
-            <a:off x="804672" y="1563624"/>
-            <a:ext cx="2377440" cy="1371600"/>
-          </a:xfrm>
-          <a:prstGeom prst="rect">
-            <a:avLst/>
-          </a:prstGeom>
-          <a:noFill/>
-        </p:spPr>
-        <p:txBody>
-          <a:bodyPr wrap="square">
-            <a:spAutoFit/>
-          </a:bodyPr>
-          <a:lstStyle/>
-          <a:p>
-            <a:pPr algn="l">
-              <a:spcBef>
-                <a:spcPts val="0"/>
-              </a:spcBef>
-              <a:spcAft>
-                <a:spcPts val="600"/>
-              </a:spcAft>
-            </a:pPr>
-            <a:r>
-              <a:rPr sz="3800" b="1" i="0">
-                <a:solidFill>
-                  <a:srgbClr val="142C3A"/>
-                </a:solidFill>
-                <a:latin typeface="Consolas"/>
-              </a:rPr>
-              <a:t>143</a:t>
-            </a:r>
-          </a:p>
-          <a:p>
-            <a:pPr algn="l">
-              <a:spcBef>
-                <a:spcPts val="200"/>
-              </a:spcBef>
-              <a:spcAft>
-                <a:spcPts val="600"/>
-              </a:spcAft>
-            </a:pPr>
-            <a:r>
-              <a:rPr sz="1250" b="0" i="0">
-                <a:solidFill>
-                  <a:srgbClr val="223038"/>
-                </a:solidFill>
-                <a:latin typeface="Calibri"/>
-              </a:rPr>
-              <a:t>interactions queued for expert review</a:t>
-            </a:r>
-          </a:p>
-        </p:txBody>
-      </p:sp>
-      <p:sp>
-        <p:nvSpPr>
-          <p:cNvPr id="9" name="Rectangle 8"/>
-          <p:cNvSpPr/>
-          <p:nvPr/>
-        </p:nvSpPr>
-        <p:spPr>
-          <a:xfrm>
-            <a:off x="3429000" y="1417320"/>
-            <a:ext cx="2743200" cy="1554480"/>
-          </a:xfrm>
-          <a:prstGeom prst="rect">
-            <a:avLst/>
-          </a:prstGeom>
-          <a:solidFill>
-            <a:srgbClr val="FFFFFF"/>
-          </a:solidFill>
-          <a:ln>
-            <a:noFill/>
-          </a:ln>
-          <a:effectLst/>
-        </p:spPr>
-        <p:style>
-          <a:lnRef idx="1">
-            <a:schemeClr val="accent1"/>
-          </a:lnRef>
-          <a:fillRef idx="3">
-            <a:schemeClr val="accent1"/>
-          </a:fillRef>
-          <a:effectRef idx="2">
-            <a:schemeClr val="accent1"/>
-          </a:effectRef>
-          <a:fontRef idx="minor">
-            <a:schemeClr val="lt1"/>
-          </a:fontRef>
-        </p:style>
-        <p:txBody>
-          <a:bodyPr rtlCol="0" anchor="ctr"/>
-          <a:lstStyle/>
-          <a:p>
-            <a:pPr algn="ctr"/>
-          </a:p>
-        </p:txBody>
-      </p:sp>
-      <p:sp>
-        <p:nvSpPr>
-          <p:cNvPr id="10" name="Rectangle 9"/>
-          <p:cNvSpPr/>
-          <p:nvPr/>
-        </p:nvSpPr>
-        <p:spPr>
-          <a:xfrm>
-            <a:off x="3429000" y="1417320"/>
-            <a:ext cx="91440" cy="1554480"/>
-          </a:xfrm>
-          <a:prstGeom prst="rect">
-            <a:avLst/>
-          </a:prstGeom>
-          <a:solidFill>
-            <a:srgbClr val="3F9E8C"/>
-          </a:solidFill>
-          <a:ln>
-            <a:noFill/>
-          </a:ln>
-          <a:effectLst/>
-        </p:spPr>
-        <p:style>
-          <a:lnRef idx="1">
-            <a:schemeClr val="accent1"/>
-          </a:lnRef>
-          <a:fillRef idx="3">
-            <a:schemeClr val="accent1"/>
-          </a:fillRef>
-          <a:effectRef idx="2">
-            <a:schemeClr val="accent1"/>
-          </a:effectRef>
-          <a:fontRef idx="minor">
-            <a:schemeClr val="lt1"/>
-          </a:fontRef>
-        </p:style>
-        <p:txBody>
-          <a:bodyPr rtlCol="0" anchor="ctr"/>
-          <a:lstStyle/>
-          <a:p>
-            <a:pPr algn="ctr"/>
-          </a:p>
-        </p:txBody>
-      </p:sp>
-      <p:sp>
-        <p:nvSpPr>
-          <p:cNvPr id="11" name="TextBox 10"/>
-          <p:cNvSpPr txBox="1"/>
-          <p:nvPr/>
-        </p:nvSpPr>
-        <p:spPr>
-          <a:xfrm>
-            <a:off x="3685032" y="1563624"/>
-            <a:ext cx="2377440" cy="1371600"/>
-          </a:xfrm>
-          <a:prstGeom prst="rect">
-            <a:avLst/>
-          </a:prstGeom>
-          <a:noFill/>
-        </p:spPr>
-        <p:txBody>
-          <a:bodyPr wrap="square">
-            <a:spAutoFit/>
-          </a:bodyPr>
-          <a:lstStyle/>
-          <a:p>
-            <a:pPr algn="l">
-              <a:spcBef>
-                <a:spcPts val="0"/>
-              </a:spcBef>
-              <a:spcAft>
-                <a:spcPts val="600"/>
-              </a:spcAft>
-            </a:pPr>
-            <a:r>
-              <a:rPr sz="3800" b="1" i="0">
-                <a:solidFill>
-                  <a:srgbClr val="3F9E8C"/>
-                </a:solidFill>
-                <a:latin typeface="Consolas"/>
-              </a:rPr>
-              <a:t>128</a:t>
-            </a:r>
-          </a:p>
-          <a:p>
-            <a:pPr algn="l">
-              <a:spcBef>
-                <a:spcPts val="200"/>
-              </a:spcBef>
-              <a:spcAft>
-                <a:spcPts val="600"/>
-              </a:spcAft>
-            </a:pPr>
-            <a:r>
-              <a:rPr sz="1250" b="0" i="0">
-                <a:solidFill>
-                  <a:srgbClr val="223038"/>
-                </a:solidFill>
-                <a:latin typeface="Calibri"/>
-              </a:rPr>
-              <a:t>passed automated AI verification</a:t>
-            </a:r>
-          </a:p>
-        </p:txBody>
-      </p:sp>
-      <p:sp>
-        <p:nvSpPr>
-          <p:cNvPr id="12" name="Rectangle 11"/>
-          <p:cNvSpPr/>
-          <p:nvPr/>
-        </p:nvSpPr>
-        <p:spPr>
-          <a:xfrm>
-            <a:off x="6309360" y="1417320"/>
-            <a:ext cx="2743200" cy="1554480"/>
-          </a:xfrm>
-          <a:prstGeom prst="rect">
-            <a:avLst/>
-          </a:prstGeom>
-          <a:solidFill>
-            <a:srgbClr val="FFFFFF"/>
-          </a:solidFill>
-          <a:ln>
-            <a:noFill/>
-          </a:ln>
-          <a:effectLst/>
-        </p:spPr>
-        <p:style>
-          <a:lnRef idx="1">
-            <a:schemeClr val="accent1"/>
-          </a:lnRef>
-          <a:fillRef idx="3">
-            <a:schemeClr val="accent1"/>
-          </a:fillRef>
-          <a:effectRef idx="2">
-            <a:schemeClr val="accent1"/>
-          </a:effectRef>
-          <a:fontRef idx="minor">
-            <a:schemeClr val="lt1"/>
-          </a:fontRef>
-        </p:style>
-        <p:txBody>
-          <a:bodyPr rtlCol="0" anchor="ctr"/>
-          <a:lstStyle/>
-          <a:p>
-            <a:pPr algn="ctr"/>
-          </a:p>
-        </p:txBody>
-      </p:sp>
-      <p:sp>
-        <p:nvSpPr>
-          <p:cNvPr id="13" name="Rectangle 12"/>
-          <p:cNvSpPr/>
-          <p:nvPr/>
-        </p:nvSpPr>
-        <p:spPr>
-          <a:xfrm>
-            <a:off x="6309360" y="1417320"/>
-            <a:ext cx="91440" cy="1554480"/>
-          </a:xfrm>
-          <a:prstGeom prst="rect">
-            <a:avLst/>
-          </a:prstGeom>
-          <a:solidFill>
-            <a:srgbClr val="E26D5A"/>
-          </a:solidFill>
-          <a:ln>
-            <a:noFill/>
-          </a:ln>
-          <a:effectLst/>
-        </p:spPr>
-        <p:style>
-          <a:lnRef idx="1">
-            <a:schemeClr val="accent1"/>
-          </a:lnRef>
-          <a:fillRef idx="3">
-            <a:schemeClr val="accent1"/>
-          </a:fillRef>
-          <a:effectRef idx="2">
-            <a:schemeClr val="accent1"/>
-          </a:effectRef>
-          <a:fontRef idx="minor">
-            <a:schemeClr val="lt1"/>
-          </a:fontRef>
-        </p:style>
-        <p:txBody>
-          <a:bodyPr rtlCol="0" anchor="ctr"/>
-          <a:lstStyle/>
-          <a:p>
-            <a:pPr algn="ctr"/>
-          </a:p>
-        </p:txBody>
-      </p:sp>
-      <p:sp>
-        <p:nvSpPr>
-          <p:cNvPr id="14" name="TextBox 13"/>
-          <p:cNvSpPr txBox="1"/>
-          <p:nvPr/>
-        </p:nvSpPr>
-        <p:spPr>
-          <a:xfrm>
-            <a:off x="6565392" y="1563624"/>
-            <a:ext cx="2377440" cy="1371600"/>
-          </a:xfrm>
-          <a:prstGeom prst="rect">
-            <a:avLst/>
-          </a:prstGeom>
-          <a:noFill/>
-        </p:spPr>
-        <p:txBody>
-          <a:bodyPr wrap="square">
-            <a:spAutoFit/>
-          </a:bodyPr>
-          <a:lstStyle/>
-          <a:p>
-            <a:pPr algn="l">
-              <a:spcBef>
-                <a:spcPts val="0"/>
-              </a:spcBef>
-              <a:spcAft>
-                <a:spcPts val="600"/>
-              </a:spcAft>
-            </a:pPr>
-            <a:r>
-              <a:rPr sz="3800" b="1" i="0">
-                <a:solidFill>
-                  <a:srgbClr val="E26D5A"/>
-                </a:solidFill>
-                <a:latin typeface="Consolas"/>
-              </a:rPr>
-              <a:t>28</a:t>
-            </a:r>
-          </a:p>
-          <a:p>
-            <a:pPr algn="l">
-              <a:spcBef>
-                <a:spcPts val="200"/>
-              </a:spcBef>
-              <a:spcAft>
-                <a:spcPts val="600"/>
-              </a:spcAft>
-            </a:pPr>
-            <a:r>
-              <a:rPr sz="1250" b="0" i="0">
-                <a:solidFill>
-                  <a:srgbClr val="223038"/>
-                </a:solidFill>
-                <a:latin typeface="Calibri"/>
-              </a:rPr>
-              <a:t>wrong source PMIDs caught &amp; fixed</a:t>
-            </a:r>
-          </a:p>
-        </p:txBody>
-      </p:sp>
-      <p:sp>
-        <p:nvSpPr>
-          <p:cNvPr id="15" name="Rectangle 14"/>
-          <p:cNvSpPr/>
-          <p:nvPr/>
-        </p:nvSpPr>
-        <p:spPr>
-          <a:xfrm>
-            <a:off x="9189720" y="1417320"/>
-            <a:ext cx="2423160" cy="1554480"/>
-          </a:xfrm>
-          <a:prstGeom prst="rect">
-            <a:avLst/>
-          </a:prstGeom>
-          <a:solidFill>
-            <a:srgbClr val="FFFFFF"/>
-          </a:solidFill>
-          <a:ln>
-            <a:noFill/>
-          </a:ln>
-          <a:effectLst/>
-        </p:spPr>
-        <p:style>
-          <a:lnRef idx="1">
-            <a:schemeClr val="accent1"/>
-          </a:lnRef>
-          <a:fillRef idx="3">
-            <a:schemeClr val="accent1"/>
-          </a:fillRef>
-          <a:effectRef idx="2">
-            <a:schemeClr val="accent1"/>
-          </a:effectRef>
-          <a:fontRef idx="minor">
-            <a:schemeClr val="lt1"/>
-          </a:fontRef>
-        </p:style>
-        <p:txBody>
-          <a:bodyPr rtlCol="0" anchor="ctr"/>
-          <a:lstStyle/>
-          <a:p>
-            <a:pPr algn="ctr"/>
-          </a:p>
-        </p:txBody>
-      </p:sp>
-      <p:sp>
-        <p:nvSpPr>
-          <p:cNvPr id="16" name="Rectangle 15"/>
-          <p:cNvSpPr/>
-          <p:nvPr/>
-        </p:nvSpPr>
-        <p:spPr>
-          <a:xfrm>
-            <a:off x="9189720" y="1417320"/>
-            <a:ext cx="91440" cy="1554480"/>
-          </a:xfrm>
-          <a:prstGeom prst="rect">
-            <a:avLst/>
-          </a:prstGeom>
-          <a:solidFill>
             <a:srgbClr val="2E8B9E"/>
           </a:solidFill>
           <a:ln>
@@ -7361,14 +7562,14 @@
       </p:sp>
       <p:sp>
         <p:nvSpPr>
-          <p:cNvPr id="17" name="TextBox 16"/>
+          <p:cNvPr id="5" name="TextBox 4"/>
           <p:cNvSpPr txBox="1"/>
           <p:nvPr/>
         </p:nvSpPr>
         <p:spPr>
           <a:xfrm>
-            <a:off x="9445752" y="1563624"/>
-            <a:ext cx="2057400" cy="1371600"/>
+            <a:off x="548640" y="109728"/>
+            <a:ext cx="11155680" cy="914400"/>
           </a:xfrm>
           <a:prstGeom prst="rect">
             <a:avLst/>
@@ -7390,46 +7591,70 @@
               </a:spcAft>
             </a:pPr>
             <a:r>
-              <a:rPr sz="3800" b="1" i="0">
+              <a:rPr sz="1200" b="1" i="0">
                 <a:solidFill>
                   <a:srgbClr val="2E8B9E"/>
                 </a:solidFill>
-                <a:latin typeface="Consolas"/>
-              </a:rPr>
-              <a:t>0</a:t>
-            </a:r>
-          </a:p>
-          <a:p>
-            <a:pPr algn="l">
-              <a:spcBef>
-                <a:spcPts val="200"/>
+                <a:latin typeface="Calibri"/>
+              </a:rPr>
+              <a:t>APPLICATION</a:t>
+            </a:r>
+          </a:p>
+          <a:p>
+            <a:pPr algn="l">
+              <a:spcBef>
+                <a:spcPts val="100"/>
               </a:spcBef>
               <a:spcAft>
                 <a:spcPts val="600"/>
               </a:spcAft>
             </a:pPr>
             <a:r>
-              <a:rPr sz="1250" b="0" i="0">
-                <a:solidFill>
-                  <a:srgbClr val="223038"/>
-                </a:solidFill>
-                <a:latin typeface="Calibri"/>
-              </a:rPr>
-              <a:t>fabricated citations</a:t>
-            </a:r>
-          </a:p>
-        </p:txBody>
-      </p:sp>
-      <p:sp>
-        <p:nvSpPr>
-          <p:cNvPr id="18" name="TextBox 17"/>
+              <a:rPr sz="2500" b="1" i="0">
+                <a:solidFill>
+                  <a:srgbClr val="FFFFFF"/>
+                </a:solidFill>
+                <a:latin typeface="Calibri"/>
+              </a:rPr>
+              <a:t>A substrate for drug prioritisation</a:t>
+            </a:r>
+          </a:p>
+        </p:txBody>
+      </p:sp>
+      <p:pic>
+        <p:nvPicPr>
+          <p:cNvPr id="6" name="Picture 5" descr="F3_druggable_targets.png"/>
+          <p:cNvPicPr>
+            <a:picLocks noChangeAspect="1"/>
+          </p:cNvPicPr>
+          <p:nvPr/>
+        </p:nvPicPr>
+        <p:blipFill>
+          <a:blip r:embed="rId2"/>
+          <a:stretch>
+            <a:fillRect/>
+          </a:stretch>
+        </p:blipFill>
+        <p:spPr>
+          <a:xfrm>
+            <a:off x="457200" y="1417320"/>
+            <a:ext cx="6537960" cy="4754880"/>
+          </a:xfrm>
+          <a:prstGeom prst="rect">
+            <a:avLst/>
+          </a:prstGeom>
+        </p:spPr>
+      </p:pic>
+      <p:sp>
+        <p:nvSpPr>
+          <p:cNvPr id="7" name="TextBox 6"/>
           <p:cNvSpPr txBox="1"/>
           <p:nvPr/>
         </p:nvSpPr>
         <p:spPr>
           <a:xfrm>
-            <a:off x="548640" y="3246120"/>
-            <a:ext cx="11064240" cy="2926080"/>
+            <a:off x="7863840" y="1554480"/>
+            <a:ext cx="3931920" cy="4572000"/>
           </a:xfrm>
           <a:prstGeom prst="rect">
             <a:avLst/>
@@ -7447,119 +7672,81 @@
                 <a:spcPts val="0"/>
               </a:spcBef>
               <a:spcAft>
-                <a:spcPts val="600"/>
-              </a:spcAft>
-            </a:pPr>
-            <a:r>
-              <a:rPr sz="1450" b="1" i="0">
-                <a:solidFill>
-                  <a:srgbClr val="142C3A"/>
-                </a:solidFill>
-                <a:latin typeface="Calibri"/>
-              </a:rPr>
-              <a:t>Contradiction detector</a:t>
-            </a:r>
-          </a:p>
-          <a:p>
-            <a:pPr algn="l">
-              <a:spcBef>
-                <a:spcPts val="0"/>
-              </a:spcBef>
-              <a:spcAft>
-                <a:spcPts val="600"/>
-              </a:spcAft>
-            </a:pPr>
-            <a:r>
-              <a:rPr sz="1450" b="0" i="0">
+                <a:spcPts val="1000"/>
+              </a:spcAft>
+            </a:pPr>
+            <a:r>
+              <a:rPr sz="1350" b="0" i="0">
                 <a:solidFill>
                   <a:srgbClr val="223038"/>
                 </a:solidFill>
                 <a:latin typeface="Calibri"/>
               </a:rPr>
-              <a:t>Flags any gene pair given opposite signs by different sources, for human arbitration.</a:t>
-            </a:r>
-          </a:p>
-          <a:p>
-            <a:pPr algn="l">
-              <a:spcBef>
-                <a:spcPts val="0"/>
-              </a:spcBef>
-              <a:spcAft>
-                <a:spcPts val="600"/>
-              </a:spcAft>
-            </a:pPr>
-            <a:r>
-              <a:rPr sz="1450" b="1" i="0">
-                <a:solidFill>
-                  <a:srgbClr val="142C3A"/>
-                </a:solidFill>
-                <a:latin typeface="Calibri"/>
-              </a:rPr>
-              <a:t>AI reviewer pass</a:t>
-            </a:r>
-          </a:p>
-          <a:p>
-            <a:pPr algn="l">
-              <a:spcBef>
-                <a:spcPts val="0"/>
-              </a:spcBef>
-              <a:spcAft>
-                <a:spcPts val="600"/>
-              </a:spcAft>
-            </a:pPr>
-            <a:r>
-              <a:rPr sz="1450" b="0" i="0">
+              <a:t>Network hubs cross-referenced with DGIdb drug–target data.</a:t>
+            </a:r>
+          </a:p>
+          <a:p>
+            <a:pPr algn="l">
+              <a:spcBef>
+                <a:spcPts val="0"/>
+              </a:spcBef>
+              <a:spcAft>
+                <a:spcPts val="1000"/>
+              </a:spcAft>
+            </a:pPr>
+            <a:r>
+              <a:rPr sz="1350" b="0" i="0">
                 <a:solidFill>
                   <a:srgbClr val="223038"/>
                 </a:solidFill>
                 <a:latin typeface="Calibri"/>
               </a:rPr>
-              <a:t>Each interaction checked against its deciding sentence + supporting/contrary abstracts — verdict: validate / revise / caution.</a:t>
-            </a:r>
-          </a:p>
-          <a:p>
-            <a:pPr algn="l">
-              <a:spcBef>
-                <a:spcPts val="0"/>
-              </a:spcBef>
-              <a:spcAft>
-                <a:spcPts val="600"/>
-              </a:spcAft>
-            </a:pPr>
-            <a:r>
-              <a:rPr sz="1450" b="1" i="0">
-                <a:solidFill>
-                  <a:srgbClr val="142C3A"/>
-                </a:solidFill>
-                <a:latin typeface="Calibri"/>
-              </a:rPr>
-              <a:t>Citation-integrity sweep (this week)</a:t>
-            </a:r>
-          </a:p>
-          <a:p>
-            <a:pPr algn="l">
-              <a:spcBef>
-                <a:spcPts val="0"/>
-              </a:spcBef>
-              <a:spcAft>
-                <a:spcPts val="600"/>
-              </a:spcAft>
-            </a:pPr>
-            <a:r>
-              <a:rPr sz="1450" b="0" i="0">
+              <a:t>Recovers targets already in SSc trials — tocilizumab (IL-6), nintedanib, romilkimab (IL-13), pamrevlumab (CTGF/CCN2), bosentan (endothelin).</a:t>
+            </a:r>
+          </a:p>
+          <a:p>
+            <a:pPr algn="l">
+              <a:spcBef>
+                <a:spcPts val="0"/>
+              </a:spcBef>
+              <a:spcAft>
+                <a:spcPts val="1000"/>
+              </a:spcAft>
+            </a:pPr>
+            <a:r>
+              <a:rPr sz="1350" b="0" i="0">
                 <a:solidFill>
                   <a:srgbClr val="223038"/>
                 </a:solidFill>
                 <a:latin typeface="Calibri"/>
               </a:rPr>
-              <a:t>Found 28 reactions whose cited PMID pointed to an unrelated paper (biology canonical, reference a data-entry slip — e.g. a TGF-β reaction cited to a rubella study). Every replacement PMID was re-verified against live PubMed before applying.</a:t>
-            </a:r>
-          </a:p>
-        </p:txBody>
-      </p:sp>
-      <p:sp>
-        <p:nvSpPr>
-          <p:cNvPr id="19" name="TextBox 18"/>
+              <a:t>Drug table recalibrated against real SSc clinical-trial outcomes.</a:t>
+            </a:r>
+          </a:p>
+          <a:p>
+            <a:pPr algn="l">
+              <a:spcBef>
+                <a:spcPts val="0"/>
+              </a:spcBef>
+              <a:spcAft>
+                <a:spcPts val="1000"/>
+              </a:spcAft>
+            </a:pPr>
+            <a:r>
+              <a:rPr sz="1350" b="0" i="0">
+                <a:solidFill>
+                  <a:srgbClr val="223038"/>
+                </a:solidFill>
+                <a:latin typeface="Calibri"/>
+              </a:rPr>
+              <a:t>Shows the map can rank and rationalise repurposing candidates.</a:t>
+            </a:r>
+          </a:p>
+        </p:txBody>
+      </p:sp>
+      <p:sp>
+        <p:nvSpPr>
+          <p:cNvPr id="8" name="TextBox 7"/>
           <p:cNvSpPr txBox="1"/>
           <p:nvPr/>
         </p:nvSpPr>
@@ -7601,7 +7788,7 @@
       </p:sp>
       <p:sp>
         <p:nvSpPr>
-          <p:cNvPr id="20" name="TextBox 19"/>
+          <p:cNvPr id="9" name="TextBox 8"/>
           <p:cNvSpPr txBox="1"/>
           <p:nvPr/>
         </p:nvSpPr>
@@ -7762,7 +7949,7 @@
             <a:avLst/>
           </a:prstGeom>
           <a:solidFill>
-            <a:srgbClr val="2E8B9E"/>
+            <a:srgbClr val="E26D5A"/>
           </a:solidFill>
           <a:ln>
             <a:noFill/>
@@ -7824,11 +8011,11 @@
             <a:r>
               <a:rPr sz="1200" b="1" i="0">
                 <a:solidFill>
-                  <a:srgbClr val="2E8B9E"/>
-                </a:solidFill>
-                <a:latin typeface="Calibri"/>
-              </a:rPr>
-              <a:t>TODAY'S TOOL</a:t>
+                  <a:srgbClr val="E26D5A"/>
+                </a:solidFill>
+                <a:latin typeface="Calibri"/>
+              </a:rPr>
+              <a:t>QUALITY CONTROL</a:t>
             </a:r>
           </a:p>
           <a:p>
@@ -7847,183 +8034,52 @@
                 </a:solidFill>
                 <a:latin typeface="Calibri"/>
               </a:rPr>
-              <a:t>An app to review the map, one interaction at a time</a:t>
-            </a:r>
-          </a:p>
-        </p:txBody>
-      </p:sp>
-      <p:sp>
-        <p:nvSpPr>
-          <p:cNvPr id="6" name="TextBox 5"/>
-          <p:cNvSpPr txBox="1"/>
-          <p:nvPr/>
-        </p:nvSpPr>
-        <p:spPr>
-          <a:xfrm>
-            <a:off x="548640" y="1463040"/>
-            <a:ext cx="6400800" cy="4754880"/>
-          </a:xfrm>
-          <a:prstGeom prst="rect">
-            <a:avLst/>
-          </a:prstGeom>
-          <a:noFill/>
-        </p:spPr>
-        <p:txBody>
-          <a:bodyPr wrap="square">
-            <a:spAutoFit/>
-          </a:bodyPr>
-          <a:lstStyle/>
-          <a:p>
-            <a:pPr algn="l">
-              <a:spcBef>
-                <a:spcPts val="0"/>
-              </a:spcBef>
-              <a:spcAft>
-                <a:spcPts val="600"/>
-              </a:spcAft>
-            </a:pPr>
-            <a:r>
-              <a:rPr sz="1450" b="1" i="0">
-                <a:solidFill>
-                  <a:srgbClr val="142C3A"/>
-                </a:solidFill>
-                <a:latin typeface="Calibri"/>
-              </a:rPr>
-              <a:t>A swipe deck for curation</a:t>
-            </a:r>
-          </a:p>
-          <a:p>
-            <a:pPr algn="l">
-              <a:spcBef>
-                <a:spcPts val="0"/>
-              </a:spcBef>
-              <a:spcAft>
-                <a:spcPts val="600"/>
-              </a:spcAft>
-            </a:pPr>
-            <a:r>
-              <a:rPr sz="1450" b="0" i="0">
-                <a:solidFill>
-                  <a:srgbClr val="223038"/>
-                </a:solidFill>
-                <a:latin typeface="Calibri"/>
-              </a:rPr>
-              <a:t>Offline, self-contained web app — one card per interaction, accept / reject / annotate.</a:t>
-            </a:r>
-          </a:p>
-          <a:p>
-            <a:pPr algn="l">
-              <a:spcBef>
-                <a:spcPts val="0"/>
-              </a:spcBef>
-              <a:spcAft>
-                <a:spcPts val="600"/>
-              </a:spcAft>
-            </a:pPr>
-            <a:r>
-              <a:rPr sz="1450" b="1" i="0">
-                <a:solidFill>
-                  <a:srgbClr val="142C3A"/>
-                </a:solidFill>
-                <a:latin typeface="Calibri"/>
-              </a:rPr>
-              <a:t>Everything you need to decide, on the card</a:t>
-            </a:r>
-          </a:p>
-          <a:p>
-            <a:pPr algn="l">
-              <a:spcBef>
-                <a:spcPts val="0"/>
-              </a:spcBef>
-              <a:spcAft>
-                <a:spcPts val="600"/>
-              </a:spcAft>
-            </a:pPr>
-            <a:r>
-              <a:rPr sz="1450" b="0" i="0">
-                <a:solidFill>
-                  <a:srgbClr val="223038"/>
-                </a:solidFill>
-                <a:latin typeface="Calibri"/>
-              </a:rPr>
-              <a:t>Regulator → target, mechanism, SSc relevance, the verbatim deciding sentence from the source article, and PubMed/DOI links.</a:t>
-            </a:r>
-          </a:p>
-          <a:p>
-            <a:pPr algn="l">
-              <a:spcBef>
-                <a:spcPts val="0"/>
-              </a:spcBef>
-              <a:spcAft>
-                <a:spcPts val="600"/>
-              </a:spcAft>
-            </a:pPr>
-            <a:r>
-              <a:rPr sz="1450" b="1" i="0">
-                <a:solidFill>
-                  <a:srgbClr val="142C3A"/>
-                </a:solidFill>
-                <a:latin typeface="Calibri"/>
-              </a:rPr>
-              <a:t>Context before you judge</a:t>
-            </a:r>
-          </a:p>
-          <a:p>
-            <a:pPr algn="l">
-              <a:spcBef>
-                <a:spcPts val="0"/>
-              </a:spcBef>
-              <a:spcAft>
-                <a:spcPts val="600"/>
-              </a:spcAft>
-            </a:pPr>
-            <a:r>
-              <a:rPr sz="1450" b="0" i="0">
-                <a:solidFill>
-                  <a:srgbClr val="223038"/>
-                </a:solidFill>
-                <a:latin typeface="Calibri"/>
-              </a:rPr>
-              <a:t>A literature dossier lists candidate supporting and “possibly contrary” references; an in-browser module map shows the neighbourhood.</a:t>
-            </a:r>
-          </a:p>
-          <a:p>
-            <a:pPr algn="l">
-              <a:spcBef>
-                <a:spcPts val="0"/>
-              </a:spcBef>
-              <a:spcAft>
-                <a:spcPts val="600"/>
-              </a:spcAft>
-            </a:pPr>
-            <a:r>
-              <a:rPr sz="1450" b="1" i="0">
-                <a:solidFill>
-                  <a:srgbClr val="142C3A"/>
-                </a:solidFill>
-                <a:latin typeface="Calibri"/>
-              </a:rPr>
-              <a:t>Advisory AI verdict</a:t>
-            </a:r>
-          </a:p>
-          <a:p>
-            <a:pPr algn="l">
-              <a:spcBef>
-                <a:spcPts val="0"/>
-              </a:spcBef>
-              <a:spcAft>
-                <a:spcPts val="600"/>
-              </a:spcAft>
-            </a:pPr>
-            <a:r>
-              <a:rPr sz="1450" b="0" i="0">
-                <a:solidFill>
-                  <a:srgbClr val="223038"/>
-                </a:solidFill>
-                <a:latin typeface="Calibri"/>
-              </a:rPr>
-              <a:t>Each card shows the AI call + rationale — filter to triage, but the human reviewer always decides.</a:t>
-            </a:r>
+              <a:t>Independent verification of every interaction</a:t>
+            </a:r>
+          </a:p>
+        </p:txBody>
+      </p:sp>
+      <p:sp>
+        <p:nvSpPr>
+          <p:cNvPr id="6" name="Rectangle 5"/>
+          <p:cNvSpPr/>
+          <p:nvPr/>
+        </p:nvSpPr>
+        <p:spPr>
+          <a:xfrm>
+            <a:off x="548640" y="1417320"/>
+            <a:ext cx="2743200" cy="1554480"/>
+          </a:xfrm>
+          <a:prstGeom prst="rect">
+            <a:avLst/>
+          </a:prstGeom>
+          <a:solidFill>
+            <a:srgbClr val="FFFFFF"/>
+          </a:solidFill>
+          <a:ln>
+            <a:noFill/>
+          </a:ln>
+          <a:effectLst/>
+        </p:spPr>
+        <p:style>
+          <a:lnRef idx="1">
+            <a:schemeClr val="accent1"/>
+          </a:lnRef>
+          <a:fillRef idx="3">
+            <a:schemeClr val="accent1"/>
+          </a:fillRef>
+          <a:effectRef idx="2">
+            <a:schemeClr val="accent1"/>
+          </a:effectRef>
+          <a:fontRef idx="minor">
+            <a:schemeClr val="lt1"/>
+          </a:fontRef>
+        </p:style>
+        <p:txBody>
+          <a:bodyPr rtlCol="0" anchor="ctr"/>
+          <a:lstStyle/>
+          <a:p>
+            <a:pPr algn="ctr"/>
           </a:p>
         </p:txBody>
       </p:sp>
@@ -8035,8 +8091,8 @@
         </p:nvSpPr>
         <p:spPr>
           <a:xfrm>
-            <a:off x="7315200" y="1554480"/>
-            <a:ext cx="4297680" cy="4389120"/>
+            <a:off x="548640" y="1417320"/>
+            <a:ext cx="91440" cy="1554480"/>
           </a:xfrm>
           <a:prstGeom prst="rect">
             <a:avLst/>
@@ -8079,8 +8135,8 @@
         </p:nvSpPr>
         <p:spPr>
           <a:xfrm>
-            <a:off x="7589520" y="1828800"/>
-            <a:ext cx="3749039" cy="3931920"/>
+            <a:off x="804672" y="1563624"/>
+            <a:ext cx="2377440" cy="1371600"/>
           </a:xfrm>
           <a:prstGeom prst="rect">
             <a:avLst/>
@@ -8098,88 +8154,138 @@
                 <a:spcPts val="0"/>
               </a:spcBef>
               <a:spcAft>
-                <a:spcPts val="1200"/>
-              </a:spcAft>
-            </a:pPr>
-            <a:r>
-              <a:rPr sz="1450" b="0" i="0">
-                <a:solidFill>
-                  <a:srgbClr val="DDE7EA"/>
-                </a:solidFill>
-                <a:latin typeface="Calibri"/>
-              </a:rPr>
-              <a:t>No install, no server — open one HTML file.</a:t>
-            </a:r>
-          </a:p>
-          <a:p>
-            <a:pPr algn="l">
-              <a:spcBef>
-                <a:spcPts val="0"/>
-              </a:spcBef>
-              <a:spcAft>
-                <a:spcPts val="1200"/>
-              </a:spcAft>
-            </a:pPr>
-            <a:r>
-              <a:rPr sz="1450" b="0" i="0">
-                <a:solidFill>
-                  <a:srgbClr val="DDE7EA"/>
-                </a:solidFill>
-                <a:latin typeface="Calibri"/>
-              </a:rPr>
-              <a:t>Decisions saved locally; export to CSV/JSON.</a:t>
-            </a:r>
-          </a:p>
-          <a:p>
-            <a:pPr algn="l">
-              <a:spcBef>
-                <a:spcPts val="0"/>
-              </a:spcBef>
-              <a:spcAft>
-                <a:spcPts val="1200"/>
-              </a:spcAft>
-            </a:pPr>
-            <a:r>
-              <a:rPr sz="1450" b="0" i="0">
-                <a:solidFill>
-                  <a:srgbClr val="DDE7EA"/>
-                </a:solidFill>
-                <a:latin typeface="Calibri"/>
-              </a:rPr>
-              <a:t>Re-includes even discarded edges, so you keep full control.</a:t>
-            </a:r>
-          </a:p>
-          <a:p>
-            <a:pPr algn="l">
-              <a:spcBef>
-                <a:spcPts val="0"/>
-              </a:spcBef>
-              <a:spcAft>
-                <a:spcPts val="1200"/>
-              </a:spcAft>
-            </a:pPr>
-            <a:r>
-              <a:rPr sz="1450" b="0" i="0">
-                <a:solidFill>
-                  <a:srgbClr val="DDE7EA"/>
-                </a:solidFill>
-                <a:latin typeface="Calibri"/>
-              </a:rPr>
-              <a:t>Demo right after this.</a:t>
-            </a:r>
-          </a:p>
-        </p:txBody>
-      </p:sp>
-      <p:sp>
-        <p:nvSpPr>
-          <p:cNvPr id="9" name="TextBox 8"/>
+                <a:spcPts val="600"/>
+              </a:spcAft>
+            </a:pPr>
+            <a:r>
+              <a:rPr sz="3800" b="1" i="0">
+                <a:solidFill>
+                  <a:srgbClr val="142C3A"/>
+                </a:solidFill>
+                <a:latin typeface="Consolas"/>
+              </a:rPr>
+              <a:t>143</a:t>
+            </a:r>
+          </a:p>
+          <a:p>
+            <a:pPr algn="l">
+              <a:spcBef>
+                <a:spcPts val="200"/>
+              </a:spcBef>
+              <a:spcAft>
+                <a:spcPts val="600"/>
+              </a:spcAft>
+            </a:pPr>
+            <a:r>
+              <a:rPr sz="1250" b="0" i="0">
+                <a:solidFill>
+                  <a:srgbClr val="223038"/>
+                </a:solidFill>
+                <a:latin typeface="Calibri"/>
+              </a:rPr>
+              <a:t>interactions queued for expert review</a:t>
+            </a:r>
+          </a:p>
+        </p:txBody>
+      </p:sp>
+      <p:sp>
+        <p:nvSpPr>
+          <p:cNvPr id="9" name="Rectangle 8"/>
+          <p:cNvSpPr/>
+          <p:nvPr/>
+        </p:nvSpPr>
+        <p:spPr>
+          <a:xfrm>
+            <a:off x="3429000" y="1417320"/>
+            <a:ext cx="2743200" cy="1554480"/>
+          </a:xfrm>
+          <a:prstGeom prst="rect">
+            <a:avLst/>
+          </a:prstGeom>
+          <a:solidFill>
+            <a:srgbClr val="FFFFFF"/>
+          </a:solidFill>
+          <a:ln>
+            <a:noFill/>
+          </a:ln>
+          <a:effectLst/>
+        </p:spPr>
+        <p:style>
+          <a:lnRef idx="1">
+            <a:schemeClr val="accent1"/>
+          </a:lnRef>
+          <a:fillRef idx="3">
+            <a:schemeClr val="accent1"/>
+          </a:fillRef>
+          <a:effectRef idx="2">
+            <a:schemeClr val="accent1"/>
+          </a:effectRef>
+          <a:fontRef idx="minor">
+            <a:schemeClr val="lt1"/>
+          </a:fontRef>
+        </p:style>
+        <p:txBody>
+          <a:bodyPr rtlCol="0" anchor="ctr"/>
+          <a:lstStyle/>
+          <a:p>
+            <a:pPr algn="ctr"/>
+          </a:p>
+        </p:txBody>
+      </p:sp>
+      <p:sp>
+        <p:nvSpPr>
+          <p:cNvPr id="10" name="Rectangle 9"/>
+          <p:cNvSpPr/>
+          <p:nvPr/>
+        </p:nvSpPr>
+        <p:spPr>
+          <a:xfrm>
+            <a:off x="3429000" y="1417320"/>
+            <a:ext cx="91440" cy="1554480"/>
+          </a:xfrm>
+          <a:prstGeom prst="rect">
+            <a:avLst/>
+          </a:prstGeom>
+          <a:solidFill>
+            <a:srgbClr val="3F9E8C"/>
+          </a:solidFill>
+          <a:ln>
+            <a:noFill/>
+          </a:ln>
+          <a:effectLst/>
+        </p:spPr>
+        <p:style>
+          <a:lnRef idx="1">
+            <a:schemeClr val="accent1"/>
+          </a:lnRef>
+          <a:fillRef idx="3">
+            <a:schemeClr val="accent1"/>
+          </a:fillRef>
+          <a:effectRef idx="2">
+            <a:schemeClr val="accent1"/>
+          </a:effectRef>
+          <a:fontRef idx="minor">
+            <a:schemeClr val="lt1"/>
+          </a:fontRef>
+        </p:style>
+        <p:txBody>
+          <a:bodyPr rtlCol="0" anchor="ctr"/>
+          <a:lstStyle/>
+          <a:p>
+            <a:pPr algn="ctr"/>
+          </a:p>
+        </p:txBody>
+      </p:sp>
+      <p:sp>
+        <p:nvSpPr>
+          <p:cNvPr id="11" name="TextBox 10"/>
           <p:cNvSpPr txBox="1"/>
           <p:nvPr/>
         </p:nvSpPr>
         <p:spPr>
           <a:xfrm>
-            <a:off x="548640" y="6437376"/>
-            <a:ext cx="8229600" cy="365760"/>
+            <a:off x="3685032" y="1563624"/>
+            <a:ext cx="2377440" cy="1371600"/>
           </a:xfrm>
           <a:prstGeom prst="rect">
             <a:avLst/>
@@ -8201,6 +8307,502 @@
               </a:spcAft>
             </a:pPr>
             <a:r>
+              <a:rPr sz="3800" b="1" i="0">
+                <a:solidFill>
+                  <a:srgbClr val="3F9E8C"/>
+                </a:solidFill>
+                <a:latin typeface="Consolas"/>
+              </a:rPr>
+              <a:t>128</a:t>
+            </a:r>
+          </a:p>
+          <a:p>
+            <a:pPr algn="l">
+              <a:spcBef>
+                <a:spcPts val="200"/>
+              </a:spcBef>
+              <a:spcAft>
+                <a:spcPts val="600"/>
+              </a:spcAft>
+            </a:pPr>
+            <a:r>
+              <a:rPr sz="1250" b="0" i="0">
+                <a:solidFill>
+                  <a:srgbClr val="223038"/>
+                </a:solidFill>
+                <a:latin typeface="Calibri"/>
+              </a:rPr>
+              <a:t>passed automated AI verification</a:t>
+            </a:r>
+          </a:p>
+        </p:txBody>
+      </p:sp>
+      <p:sp>
+        <p:nvSpPr>
+          <p:cNvPr id="12" name="Rectangle 11"/>
+          <p:cNvSpPr/>
+          <p:nvPr/>
+        </p:nvSpPr>
+        <p:spPr>
+          <a:xfrm>
+            <a:off x="6309360" y="1417320"/>
+            <a:ext cx="2743200" cy="1554480"/>
+          </a:xfrm>
+          <a:prstGeom prst="rect">
+            <a:avLst/>
+          </a:prstGeom>
+          <a:solidFill>
+            <a:srgbClr val="FFFFFF"/>
+          </a:solidFill>
+          <a:ln>
+            <a:noFill/>
+          </a:ln>
+          <a:effectLst/>
+        </p:spPr>
+        <p:style>
+          <a:lnRef idx="1">
+            <a:schemeClr val="accent1"/>
+          </a:lnRef>
+          <a:fillRef idx="3">
+            <a:schemeClr val="accent1"/>
+          </a:fillRef>
+          <a:effectRef idx="2">
+            <a:schemeClr val="accent1"/>
+          </a:effectRef>
+          <a:fontRef idx="minor">
+            <a:schemeClr val="lt1"/>
+          </a:fontRef>
+        </p:style>
+        <p:txBody>
+          <a:bodyPr rtlCol="0" anchor="ctr"/>
+          <a:lstStyle/>
+          <a:p>
+            <a:pPr algn="ctr"/>
+          </a:p>
+        </p:txBody>
+      </p:sp>
+      <p:sp>
+        <p:nvSpPr>
+          <p:cNvPr id="13" name="Rectangle 12"/>
+          <p:cNvSpPr/>
+          <p:nvPr/>
+        </p:nvSpPr>
+        <p:spPr>
+          <a:xfrm>
+            <a:off x="6309360" y="1417320"/>
+            <a:ext cx="91440" cy="1554480"/>
+          </a:xfrm>
+          <a:prstGeom prst="rect">
+            <a:avLst/>
+          </a:prstGeom>
+          <a:solidFill>
+            <a:srgbClr val="E26D5A"/>
+          </a:solidFill>
+          <a:ln>
+            <a:noFill/>
+          </a:ln>
+          <a:effectLst/>
+        </p:spPr>
+        <p:style>
+          <a:lnRef idx="1">
+            <a:schemeClr val="accent1"/>
+          </a:lnRef>
+          <a:fillRef idx="3">
+            <a:schemeClr val="accent1"/>
+          </a:fillRef>
+          <a:effectRef idx="2">
+            <a:schemeClr val="accent1"/>
+          </a:effectRef>
+          <a:fontRef idx="minor">
+            <a:schemeClr val="lt1"/>
+          </a:fontRef>
+        </p:style>
+        <p:txBody>
+          <a:bodyPr rtlCol="0" anchor="ctr"/>
+          <a:lstStyle/>
+          <a:p>
+            <a:pPr algn="ctr"/>
+          </a:p>
+        </p:txBody>
+      </p:sp>
+      <p:sp>
+        <p:nvSpPr>
+          <p:cNvPr id="14" name="TextBox 13"/>
+          <p:cNvSpPr txBox="1"/>
+          <p:nvPr/>
+        </p:nvSpPr>
+        <p:spPr>
+          <a:xfrm>
+            <a:off x="6565392" y="1563624"/>
+            <a:ext cx="2377440" cy="1371600"/>
+          </a:xfrm>
+          <a:prstGeom prst="rect">
+            <a:avLst/>
+          </a:prstGeom>
+          <a:noFill/>
+        </p:spPr>
+        <p:txBody>
+          <a:bodyPr wrap="square">
+            <a:spAutoFit/>
+          </a:bodyPr>
+          <a:lstStyle/>
+          <a:p>
+            <a:pPr algn="l">
+              <a:spcBef>
+                <a:spcPts val="0"/>
+              </a:spcBef>
+              <a:spcAft>
+                <a:spcPts val="600"/>
+              </a:spcAft>
+            </a:pPr>
+            <a:r>
+              <a:rPr sz="3800" b="1" i="0">
+                <a:solidFill>
+                  <a:srgbClr val="E26D5A"/>
+                </a:solidFill>
+                <a:latin typeface="Consolas"/>
+              </a:rPr>
+              <a:t>28</a:t>
+            </a:r>
+          </a:p>
+          <a:p>
+            <a:pPr algn="l">
+              <a:spcBef>
+                <a:spcPts val="200"/>
+              </a:spcBef>
+              <a:spcAft>
+                <a:spcPts val="600"/>
+              </a:spcAft>
+            </a:pPr>
+            <a:r>
+              <a:rPr sz="1250" b="0" i="0">
+                <a:solidFill>
+                  <a:srgbClr val="223038"/>
+                </a:solidFill>
+                <a:latin typeface="Calibri"/>
+              </a:rPr>
+              <a:t>wrong source PMIDs caught &amp; fixed</a:t>
+            </a:r>
+          </a:p>
+        </p:txBody>
+      </p:sp>
+      <p:sp>
+        <p:nvSpPr>
+          <p:cNvPr id="15" name="Rectangle 14"/>
+          <p:cNvSpPr/>
+          <p:nvPr/>
+        </p:nvSpPr>
+        <p:spPr>
+          <a:xfrm>
+            <a:off x="9189720" y="1417320"/>
+            <a:ext cx="2423160" cy="1554480"/>
+          </a:xfrm>
+          <a:prstGeom prst="rect">
+            <a:avLst/>
+          </a:prstGeom>
+          <a:solidFill>
+            <a:srgbClr val="FFFFFF"/>
+          </a:solidFill>
+          <a:ln>
+            <a:noFill/>
+          </a:ln>
+          <a:effectLst/>
+        </p:spPr>
+        <p:style>
+          <a:lnRef idx="1">
+            <a:schemeClr val="accent1"/>
+          </a:lnRef>
+          <a:fillRef idx="3">
+            <a:schemeClr val="accent1"/>
+          </a:fillRef>
+          <a:effectRef idx="2">
+            <a:schemeClr val="accent1"/>
+          </a:effectRef>
+          <a:fontRef idx="minor">
+            <a:schemeClr val="lt1"/>
+          </a:fontRef>
+        </p:style>
+        <p:txBody>
+          <a:bodyPr rtlCol="0" anchor="ctr"/>
+          <a:lstStyle/>
+          <a:p>
+            <a:pPr algn="ctr"/>
+          </a:p>
+        </p:txBody>
+      </p:sp>
+      <p:sp>
+        <p:nvSpPr>
+          <p:cNvPr id="16" name="Rectangle 15"/>
+          <p:cNvSpPr/>
+          <p:nvPr/>
+        </p:nvSpPr>
+        <p:spPr>
+          <a:xfrm>
+            <a:off x="9189720" y="1417320"/>
+            <a:ext cx="91440" cy="1554480"/>
+          </a:xfrm>
+          <a:prstGeom prst="rect">
+            <a:avLst/>
+          </a:prstGeom>
+          <a:solidFill>
+            <a:srgbClr val="2E8B9E"/>
+          </a:solidFill>
+          <a:ln>
+            <a:noFill/>
+          </a:ln>
+          <a:effectLst/>
+        </p:spPr>
+        <p:style>
+          <a:lnRef idx="1">
+            <a:schemeClr val="accent1"/>
+          </a:lnRef>
+          <a:fillRef idx="3">
+            <a:schemeClr val="accent1"/>
+          </a:fillRef>
+          <a:effectRef idx="2">
+            <a:schemeClr val="accent1"/>
+          </a:effectRef>
+          <a:fontRef idx="minor">
+            <a:schemeClr val="lt1"/>
+          </a:fontRef>
+        </p:style>
+        <p:txBody>
+          <a:bodyPr rtlCol="0" anchor="ctr"/>
+          <a:lstStyle/>
+          <a:p>
+            <a:pPr algn="ctr"/>
+          </a:p>
+        </p:txBody>
+      </p:sp>
+      <p:sp>
+        <p:nvSpPr>
+          <p:cNvPr id="17" name="TextBox 16"/>
+          <p:cNvSpPr txBox="1"/>
+          <p:nvPr/>
+        </p:nvSpPr>
+        <p:spPr>
+          <a:xfrm>
+            <a:off x="9445752" y="1563624"/>
+            <a:ext cx="2057400" cy="1371600"/>
+          </a:xfrm>
+          <a:prstGeom prst="rect">
+            <a:avLst/>
+          </a:prstGeom>
+          <a:noFill/>
+        </p:spPr>
+        <p:txBody>
+          <a:bodyPr wrap="square">
+            <a:spAutoFit/>
+          </a:bodyPr>
+          <a:lstStyle/>
+          <a:p>
+            <a:pPr algn="l">
+              <a:spcBef>
+                <a:spcPts val="0"/>
+              </a:spcBef>
+              <a:spcAft>
+                <a:spcPts val="600"/>
+              </a:spcAft>
+            </a:pPr>
+            <a:r>
+              <a:rPr sz="3800" b="1" i="0">
+                <a:solidFill>
+                  <a:srgbClr val="2E8B9E"/>
+                </a:solidFill>
+                <a:latin typeface="Consolas"/>
+              </a:rPr>
+              <a:t>0</a:t>
+            </a:r>
+          </a:p>
+          <a:p>
+            <a:pPr algn="l">
+              <a:spcBef>
+                <a:spcPts val="200"/>
+              </a:spcBef>
+              <a:spcAft>
+                <a:spcPts val="600"/>
+              </a:spcAft>
+            </a:pPr>
+            <a:r>
+              <a:rPr sz="1250" b="0" i="0">
+                <a:solidFill>
+                  <a:srgbClr val="223038"/>
+                </a:solidFill>
+                <a:latin typeface="Calibri"/>
+              </a:rPr>
+              <a:t>fabricated citations</a:t>
+            </a:r>
+          </a:p>
+        </p:txBody>
+      </p:sp>
+      <p:sp>
+        <p:nvSpPr>
+          <p:cNvPr id="18" name="TextBox 17"/>
+          <p:cNvSpPr txBox="1"/>
+          <p:nvPr/>
+        </p:nvSpPr>
+        <p:spPr>
+          <a:xfrm>
+            <a:off x="548640" y="3246120"/>
+            <a:ext cx="11064240" cy="2926080"/>
+          </a:xfrm>
+          <a:prstGeom prst="rect">
+            <a:avLst/>
+          </a:prstGeom>
+          <a:noFill/>
+        </p:spPr>
+        <p:txBody>
+          <a:bodyPr wrap="square">
+            <a:spAutoFit/>
+          </a:bodyPr>
+          <a:lstStyle/>
+          <a:p>
+            <a:pPr algn="l">
+              <a:spcBef>
+                <a:spcPts val="0"/>
+              </a:spcBef>
+              <a:spcAft>
+                <a:spcPts val="600"/>
+              </a:spcAft>
+            </a:pPr>
+            <a:r>
+              <a:rPr sz="1450" b="1" i="0">
+                <a:solidFill>
+                  <a:srgbClr val="142C3A"/>
+                </a:solidFill>
+                <a:latin typeface="Calibri"/>
+              </a:rPr>
+              <a:t>Contradiction detector</a:t>
+            </a:r>
+          </a:p>
+          <a:p>
+            <a:pPr algn="l">
+              <a:spcBef>
+                <a:spcPts val="0"/>
+              </a:spcBef>
+              <a:spcAft>
+                <a:spcPts val="600"/>
+              </a:spcAft>
+            </a:pPr>
+            <a:r>
+              <a:rPr sz="1450" b="0" i="0">
+                <a:solidFill>
+                  <a:srgbClr val="223038"/>
+                </a:solidFill>
+                <a:latin typeface="Calibri"/>
+              </a:rPr>
+              <a:t>Flags any gene pair given opposite signs by different sources, for human arbitration.</a:t>
+            </a:r>
+          </a:p>
+          <a:p>
+            <a:pPr algn="l">
+              <a:spcBef>
+                <a:spcPts val="0"/>
+              </a:spcBef>
+              <a:spcAft>
+                <a:spcPts val="600"/>
+              </a:spcAft>
+            </a:pPr>
+            <a:r>
+              <a:rPr sz="1450" b="1" i="0">
+                <a:solidFill>
+                  <a:srgbClr val="142C3A"/>
+                </a:solidFill>
+                <a:latin typeface="Calibri"/>
+              </a:rPr>
+              <a:t>AI reviewer pass</a:t>
+            </a:r>
+          </a:p>
+          <a:p>
+            <a:pPr algn="l">
+              <a:spcBef>
+                <a:spcPts val="0"/>
+              </a:spcBef>
+              <a:spcAft>
+                <a:spcPts val="600"/>
+              </a:spcAft>
+            </a:pPr>
+            <a:r>
+              <a:rPr sz="1450" b="0" i="0">
+                <a:solidFill>
+                  <a:srgbClr val="223038"/>
+                </a:solidFill>
+                <a:latin typeface="Calibri"/>
+              </a:rPr>
+              <a:t>Each interaction checked against its deciding sentence + supporting/contrary abstracts — verdict: validate / revise / caution.</a:t>
+            </a:r>
+          </a:p>
+          <a:p>
+            <a:pPr algn="l">
+              <a:spcBef>
+                <a:spcPts val="0"/>
+              </a:spcBef>
+              <a:spcAft>
+                <a:spcPts val="600"/>
+              </a:spcAft>
+            </a:pPr>
+            <a:r>
+              <a:rPr sz="1450" b="1" i="0">
+                <a:solidFill>
+                  <a:srgbClr val="142C3A"/>
+                </a:solidFill>
+                <a:latin typeface="Calibri"/>
+              </a:rPr>
+              <a:t>Citation-integrity sweep (this week)</a:t>
+            </a:r>
+          </a:p>
+          <a:p>
+            <a:pPr algn="l">
+              <a:spcBef>
+                <a:spcPts val="0"/>
+              </a:spcBef>
+              <a:spcAft>
+                <a:spcPts val="600"/>
+              </a:spcAft>
+            </a:pPr>
+            <a:r>
+              <a:rPr sz="1450" b="0" i="0">
+                <a:solidFill>
+                  <a:srgbClr val="223038"/>
+                </a:solidFill>
+                <a:latin typeface="Calibri"/>
+              </a:rPr>
+              <a:t>Found 28 reactions whose cited PMID pointed to an unrelated paper (biology canonical, reference a data-entry slip — e.g. a TGF-β reaction cited to a rubella study). Every replacement PMID was re-verified against live PubMed before applying.</a:t>
+            </a:r>
+          </a:p>
+        </p:txBody>
+      </p:sp>
+      <p:sp>
+        <p:nvSpPr>
+          <p:cNvPr id="19" name="TextBox 18"/>
+          <p:cNvSpPr txBox="1"/>
+          <p:nvPr/>
+        </p:nvSpPr>
+        <p:spPr>
+          <a:xfrm>
+            <a:off x="548640" y="6437376"/>
+            <a:ext cx="8229600" cy="365760"/>
+          </a:xfrm>
+          <a:prstGeom prst="rect">
+            <a:avLst/>
+          </a:prstGeom>
+          <a:noFill/>
+        </p:spPr>
+        <p:txBody>
+          <a:bodyPr wrap="square">
+            <a:spAutoFit/>
+          </a:bodyPr>
+          <a:lstStyle/>
+          <a:p>
+            <a:pPr algn="l">
+              <a:spcBef>
+                <a:spcPts val="0"/>
+              </a:spcBef>
+              <a:spcAft>
+                <a:spcPts val="600"/>
+              </a:spcAft>
+            </a:pPr>
+            <a:r>
               <a:rPr sz="900" b="0" i="0">
                 <a:solidFill>
                   <a:srgbClr val="6B7A82"/>
@@ -8214,7 +8816,7 @@
       </p:sp>
       <p:sp>
         <p:nvSpPr>
-          <p:cNvPr id="10" name="TextBox 9"/>
+          <p:cNvPr id="20" name="TextBox 19"/>
           <p:cNvSpPr txBox="1"/>
           <p:nvPr/>
         </p:nvSpPr>
@@ -8375,7 +8977,7 @@
             <a:avLst/>
           </a:prstGeom>
           <a:solidFill>
-            <a:srgbClr val="E26D5A"/>
+            <a:srgbClr val="2E8B9E"/>
           </a:solidFill>
           <a:ln>
             <a:noFill/>
@@ -8437,11 +9039,11 @@
             <a:r>
               <a:rPr sz="1200" b="1" i="0">
                 <a:solidFill>
-                  <a:srgbClr val="E26D5A"/>
-                </a:solidFill>
-                <a:latin typeface="Calibri"/>
-              </a:rPr>
-              <a:t>WHAT WE ASK OF YOU</a:t>
+                  <a:srgbClr val="2E8B9E"/>
+                </a:solidFill>
+                <a:latin typeface="Calibri"/>
+              </a:rPr>
+              <a:t>TODAY'S TOOL</a:t>
             </a:r>
           </a:p>
           <a:p>
@@ -8460,27 +9062,202 @@
                 </a:solidFill>
                 <a:latin typeface="Calibri"/>
               </a:rPr>
-              <a:t>Three things from expert biologists</a:t>
-            </a:r>
-          </a:p>
-        </p:txBody>
-      </p:sp>
-      <p:sp>
-        <p:nvSpPr>
-          <p:cNvPr id="6" name="Rectangle 5"/>
+              <a:t>An app to review the map, one interaction at a time</a:t>
+            </a:r>
+          </a:p>
+        </p:txBody>
+      </p:sp>
+      <p:sp>
+        <p:nvSpPr>
+          <p:cNvPr id="6" name="TextBox 5"/>
+          <p:cNvSpPr txBox="1"/>
+          <p:nvPr/>
+        </p:nvSpPr>
+        <p:spPr>
+          <a:xfrm>
+            <a:off x="548640" y="1463040"/>
+            <a:ext cx="6400800" cy="4754880"/>
+          </a:xfrm>
+          <a:prstGeom prst="rect">
+            <a:avLst/>
+          </a:prstGeom>
+          <a:noFill/>
+        </p:spPr>
+        <p:txBody>
+          <a:bodyPr wrap="square">
+            <a:spAutoFit/>
+          </a:bodyPr>
+          <a:lstStyle/>
+          <a:p>
+            <a:pPr algn="l">
+              <a:spcBef>
+                <a:spcPts val="0"/>
+              </a:spcBef>
+              <a:spcAft>
+                <a:spcPts val="600"/>
+              </a:spcAft>
+            </a:pPr>
+            <a:r>
+              <a:rPr sz="1450" b="1" i="0">
+                <a:solidFill>
+                  <a:srgbClr val="142C3A"/>
+                </a:solidFill>
+                <a:latin typeface="Calibri"/>
+              </a:rPr>
+              <a:t>A swipe deck for curation</a:t>
+            </a:r>
+          </a:p>
+          <a:p>
+            <a:pPr algn="l">
+              <a:spcBef>
+                <a:spcPts val="0"/>
+              </a:spcBef>
+              <a:spcAft>
+                <a:spcPts val="600"/>
+              </a:spcAft>
+            </a:pPr>
+            <a:r>
+              <a:rPr sz="1450" b="0" i="0">
+                <a:solidFill>
+                  <a:srgbClr val="223038"/>
+                </a:solidFill>
+                <a:latin typeface="Calibri"/>
+              </a:rPr>
+              <a:t>Offline, self-contained web app — one card per interaction, accept / reject / annotate.</a:t>
+            </a:r>
+          </a:p>
+          <a:p>
+            <a:pPr algn="l">
+              <a:spcBef>
+                <a:spcPts val="0"/>
+              </a:spcBef>
+              <a:spcAft>
+                <a:spcPts val="600"/>
+              </a:spcAft>
+            </a:pPr>
+            <a:r>
+              <a:rPr sz="1450" b="1" i="0">
+                <a:solidFill>
+                  <a:srgbClr val="142C3A"/>
+                </a:solidFill>
+                <a:latin typeface="Calibri"/>
+              </a:rPr>
+              <a:t>Everything you need to decide, on the card</a:t>
+            </a:r>
+          </a:p>
+          <a:p>
+            <a:pPr algn="l">
+              <a:spcBef>
+                <a:spcPts val="0"/>
+              </a:spcBef>
+              <a:spcAft>
+                <a:spcPts val="600"/>
+              </a:spcAft>
+            </a:pPr>
+            <a:r>
+              <a:rPr sz="1450" b="0" i="0">
+                <a:solidFill>
+                  <a:srgbClr val="223038"/>
+                </a:solidFill>
+                <a:latin typeface="Calibri"/>
+              </a:rPr>
+              <a:t>Regulator → target, mechanism, SSc relevance, the verbatim deciding sentence from the source article, and PubMed/DOI links.</a:t>
+            </a:r>
+          </a:p>
+          <a:p>
+            <a:pPr algn="l">
+              <a:spcBef>
+                <a:spcPts val="0"/>
+              </a:spcBef>
+              <a:spcAft>
+                <a:spcPts val="600"/>
+              </a:spcAft>
+            </a:pPr>
+            <a:r>
+              <a:rPr sz="1450" b="1" i="0">
+                <a:solidFill>
+                  <a:srgbClr val="142C3A"/>
+                </a:solidFill>
+                <a:latin typeface="Calibri"/>
+              </a:rPr>
+              <a:t>Context before you judge</a:t>
+            </a:r>
+          </a:p>
+          <a:p>
+            <a:pPr algn="l">
+              <a:spcBef>
+                <a:spcPts val="0"/>
+              </a:spcBef>
+              <a:spcAft>
+                <a:spcPts val="600"/>
+              </a:spcAft>
+            </a:pPr>
+            <a:r>
+              <a:rPr sz="1450" b="0" i="0">
+                <a:solidFill>
+                  <a:srgbClr val="223038"/>
+                </a:solidFill>
+                <a:latin typeface="Calibri"/>
+              </a:rPr>
+              <a:t>A literature dossier lists candidate supporting and “possibly contrary” references; an in-browser module map shows the neighbourhood.</a:t>
+            </a:r>
+          </a:p>
+          <a:p>
+            <a:pPr algn="l">
+              <a:spcBef>
+                <a:spcPts val="0"/>
+              </a:spcBef>
+              <a:spcAft>
+                <a:spcPts val="600"/>
+              </a:spcAft>
+            </a:pPr>
+            <a:r>
+              <a:rPr sz="1450" b="1" i="0">
+                <a:solidFill>
+                  <a:srgbClr val="142C3A"/>
+                </a:solidFill>
+                <a:latin typeface="Calibri"/>
+              </a:rPr>
+              <a:t>Advisory AI verdict</a:t>
+            </a:r>
+          </a:p>
+          <a:p>
+            <a:pPr algn="l">
+              <a:spcBef>
+                <a:spcPts val="0"/>
+              </a:spcBef>
+              <a:spcAft>
+                <a:spcPts val="600"/>
+              </a:spcAft>
+            </a:pPr>
+            <a:r>
+              <a:rPr sz="1450" b="0" i="0">
+                <a:solidFill>
+                  <a:srgbClr val="223038"/>
+                </a:solidFill>
+                <a:latin typeface="Calibri"/>
+              </a:rPr>
+              <a:t>Each card shows the AI call + rationale — filter to triage, but the human reviewer always decides.</a:t>
+            </a:r>
+          </a:p>
+        </p:txBody>
+      </p:sp>
+      <p:sp>
+        <p:nvSpPr>
+          <p:cNvPr id="7" name="Rectangle 6"/>
           <p:cNvSpPr/>
           <p:nvPr/>
         </p:nvSpPr>
         <p:spPr>
           <a:xfrm>
-            <a:off x="548640" y="1554480"/>
-            <a:ext cx="3611880" cy="4023360"/>
+            <a:off x="7315200" y="1554480"/>
+            <a:ext cx="4297680" cy="4389120"/>
           </a:xfrm>
           <a:prstGeom prst="rect">
             <a:avLst/>
           </a:prstGeom>
           <a:solidFill>
-            <a:srgbClr val="FFFFFF"/>
+            <a:srgbClr val="142C3A"/>
           </a:solidFill>
           <a:ln>
             <a:noFill/>
@@ -8511,118 +9288,14 @@
       </p:sp>
       <p:sp>
         <p:nvSpPr>
-          <p:cNvPr id="7" name="Rectangle 6"/>
-          <p:cNvSpPr/>
-          <p:nvPr/>
-        </p:nvSpPr>
-        <p:spPr>
-          <a:xfrm>
-            <a:off x="548640" y="1554480"/>
-            <a:ext cx="3611880" cy="82296"/>
-          </a:xfrm>
-          <a:prstGeom prst="rect">
-            <a:avLst/>
-          </a:prstGeom>
-          <a:solidFill>
-            <a:srgbClr val="3A73B8"/>
-          </a:solidFill>
-          <a:ln>
-            <a:noFill/>
-          </a:ln>
-          <a:effectLst/>
-        </p:spPr>
-        <p:style>
-          <a:lnRef idx="1">
-            <a:schemeClr val="accent1"/>
-          </a:lnRef>
-          <a:fillRef idx="3">
-            <a:schemeClr val="accent1"/>
-          </a:fillRef>
-          <a:effectRef idx="2">
-            <a:schemeClr val="accent1"/>
-          </a:effectRef>
-          <a:fontRef idx="minor">
-            <a:schemeClr val="lt1"/>
-          </a:fontRef>
-        </p:style>
-        <p:txBody>
-          <a:bodyPr rtlCol="0" anchor="ctr"/>
-          <a:lstStyle/>
-          <a:p>
-            <a:pPr algn="ctr"/>
-          </a:p>
-        </p:txBody>
-      </p:sp>
-      <p:sp>
-        <p:nvSpPr>
-          <p:cNvPr id="8" name="Oval 7"/>
-          <p:cNvSpPr/>
-          <p:nvPr/>
-        </p:nvSpPr>
-        <p:spPr>
-          <a:xfrm>
-            <a:off x="822959" y="1874519"/>
-            <a:ext cx="868680" cy="868680"/>
-          </a:xfrm>
-          <a:prstGeom prst="ellipse">
-            <a:avLst/>
-          </a:prstGeom>
-          <a:solidFill>
-            <a:srgbClr val="3A73B8"/>
-          </a:solidFill>
-          <a:ln>
-            <a:noFill/>
-          </a:ln>
-          <a:effectLst/>
-        </p:spPr>
-        <p:style>
-          <a:lnRef idx="1">
-            <a:schemeClr val="accent1"/>
-          </a:lnRef>
-          <a:fillRef idx="3">
-            <a:schemeClr val="accent1"/>
-          </a:fillRef>
-          <a:effectRef idx="2">
-            <a:schemeClr val="accent1"/>
-          </a:effectRef>
-          <a:fontRef idx="minor">
-            <a:schemeClr val="lt1"/>
-          </a:fontRef>
-        </p:style>
-        <p:txBody>
-          <a:bodyPr rtlCol="0" anchor="ctr"/>
-          <a:lstStyle/>
-          <a:p>
-            <a:pPr algn="ctr">
-              <a:spcBef>
-                <a:spcPts val="0"/>
-              </a:spcBef>
-              <a:spcAft>
-                <a:spcPts val="600"/>
-              </a:spcAft>
-            </a:pPr>
-            <a:r>
-              <a:rPr sz="2800" b="1" i="0">
-                <a:solidFill>
-                  <a:srgbClr val="FFFFFF"/>
-                </a:solidFill>
-                <a:latin typeface="Calibri"/>
-              </a:rPr>
-              <a:t>1</a:t>
-            </a:r>
-          </a:p>
-        </p:txBody>
-      </p:sp>
-      <p:sp>
-        <p:nvSpPr>
-          <p:cNvPr id="9" name="TextBox 8"/>
+          <p:cNvPr id="8" name="TextBox 7"/>
           <p:cNvSpPr txBox="1"/>
           <p:nvPr/>
         </p:nvSpPr>
         <p:spPr>
           <a:xfrm>
-            <a:off x="841247" y="2971800"/>
-            <a:ext cx="3063240" cy="2468880"/>
+            <a:off x="7589520" y="1828800"/>
+            <a:ext cx="3749039" cy="3931920"/>
           </a:xfrm>
           <a:prstGeom prst="rect">
             <a:avLst/>
@@ -8640,198 +9313,88 @@
                 <a:spcPts val="0"/>
               </a:spcBef>
               <a:spcAft>
-                <a:spcPts val="800"/>
-              </a:spcAft>
-            </a:pPr>
-            <a:r>
-              <a:rPr sz="1800" b="1" i="0">
-                <a:solidFill>
-                  <a:srgbClr val="142C3A"/>
-                </a:solidFill>
-                <a:latin typeface="Calibri"/>
-              </a:rPr>
-              <a:t>Validate the scope</a:t>
-            </a:r>
-          </a:p>
-          <a:p>
-            <a:pPr algn="l">
-              <a:spcBef>
-                <a:spcPts val="0"/>
-              </a:spcBef>
-              <a:spcAft>
-                <a:spcPts val="600"/>
+                <a:spcPts val="1200"/>
               </a:spcAft>
             </a:pPr>
             <a:r>
               <a:rPr sz="1450" b="0" i="0">
                 <a:solidFill>
-                  <a:srgbClr val="223038"/>
-                </a:solidFill>
-                <a:latin typeface="Calibri"/>
-              </a:rPr>
-              <a:t>Do the 4 modules + phenotype sinks capture dcSSc skin fibrosis? What is missing or over-reaching?</a:t>
-            </a:r>
-          </a:p>
-        </p:txBody>
-      </p:sp>
-      <p:sp>
-        <p:nvSpPr>
-          <p:cNvPr id="10" name="Rectangle 9"/>
-          <p:cNvSpPr/>
-          <p:nvPr/>
-        </p:nvSpPr>
-        <p:spPr>
-          <a:xfrm>
-            <a:off x="4315968" y="1554480"/>
-            <a:ext cx="3611880" cy="4023360"/>
-          </a:xfrm>
-          <a:prstGeom prst="rect">
-            <a:avLst/>
-          </a:prstGeom>
-          <a:solidFill>
-            <a:srgbClr val="FFFFFF"/>
-          </a:solidFill>
-          <a:ln>
-            <a:noFill/>
-          </a:ln>
-          <a:effectLst/>
-        </p:spPr>
-        <p:style>
-          <a:lnRef idx="1">
-            <a:schemeClr val="accent1"/>
-          </a:lnRef>
-          <a:fillRef idx="3">
-            <a:schemeClr val="accent1"/>
-          </a:fillRef>
-          <a:effectRef idx="2">
-            <a:schemeClr val="accent1"/>
-          </a:effectRef>
-          <a:fontRef idx="minor">
-            <a:schemeClr val="lt1"/>
-          </a:fontRef>
-        </p:style>
-        <p:txBody>
-          <a:bodyPr rtlCol="0" anchor="ctr"/>
-          <a:lstStyle/>
-          <a:p>
-            <a:pPr algn="ctr"/>
-          </a:p>
-        </p:txBody>
-      </p:sp>
-      <p:sp>
-        <p:nvSpPr>
-          <p:cNvPr id="11" name="Rectangle 10"/>
-          <p:cNvSpPr/>
-          <p:nvPr/>
-        </p:nvSpPr>
-        <p:spPr>
-          <a:xfrm>
-            <a:off x="4315968" y="1554480"/>
-            <a:ext cx="3611880" cy="82296"/>
-          </a:xfrm>
-          <a:prstGeom prst="rect">
-            <a:avLst/>
-          </a:prstGeom>
-          <a:solidFill>
-            <a:srgbClr val="E26D5A"/>
-          </a:solidFill>
-          <a:ln>
-            <a:noFill/>
-          </a:ln>
-          <a:effectLst/>
-        </p:spPr>
-        <p:style>
-          <a:lnRef idx="1">
-            <a:schemeClr val="accent1"/>
-          </a:lnRef>
-          <a:fillRef idx="3">
-            <a:schemeClr val="accent1"/>
-          </a:fillRef>
-          <a:effectRef idx="2">
-            <a:schemeClr val="accent1"/>
-          </a:effectRef>
-          <a:fontRef idx="minor">
-            <a:schemeClr val="lt1"/>
-          </a:fontRef>
-        </p:style>
-        <p:txBody>
-          <a:bodyPr rtlCol="0" anchor="ctr"/>
-          <a:lstStyle/>
-          <a:p>
-            <a:pPr algn="ctr"/>
-          </a:p>
-        </p:txBody>
-      </p:sp>
-      <p:sp>
-        <p:nvSpPr>
-          <p:cNvPr id="12" name="Oval 11"/>
-          <p:cNvSpPr/>
-          <p:nvPr/>
-        </p:nvSpPr>
-        <p:spPr>
-          <a:xfrm>
-            <a:off x="4590288" y="1874519"/>
-            <a:ext cx="868680" cy="868680"/>
-          </a:xfrm>
-          <a:prstGeom prst="ellipse">
-            <a:avLst/>
-          </a:prstGeom>
-          <a:solidFill>
-            <a:srgbClr val="E26D5A"/>
-          </a:solidFill>
-          <a:ln>
-            <a:noFill/>
-          </a:ln>
-          <a:effectLst/>
-        </p:spPr>
-        <p:style>
-          <a:lnRef idx="1">
-            <a:schemeClr val="accent1"/>
-          </a:lnRef>
-          <a:fillRef idx="3">
-            <a:schemeClr val="accent1"/>
-          </a:fillRef>
-          <a:effectRef idx="2">
-            <a:schemeClr val="accent1"/>
-          </a:effectRef>
-          <a:fontRef idx="minor">
-            <a:schemeClr val="lt1"/>
-          </a:fontRef>
-        </p:style>
-        <p:txBody>
-          <a:bodyPr rtlCol="0" anchor="ctr"/>
-          <a:lstStyle/>
-          <a:p>
-            <a:pPr algn="ctr">
-              <a:spcBef>
-                <a:spcPts val="0"/>
-              </a:spcBef>
-              <a:spcAft>
-                <a:spcPts val="600"/>
-              </a:spcAft>
-            </a:pPr>
-            <a:r>
-              <a:rPr sz="2800" b="1" i="0">
-                <a:solidFill>
-                  <a:srgbClr val="FFFFFF"/>
-                </a:solidFill>
-                <a:latin typeface="Calibri"/>
-              </a:rPr>
-              <a:t>2</a:t>
-            </a:r>
-          </a:p>
-        </p:txBody>
-      </p:sp>
-      <p:sp>
-        <p:nvSpPr>
-          <p:cNvPr id="13" name="TextBox 12"/>
+                  <a:srgbClr val="DDE7EA"/>
+                </a:solidFill>
+                <a:latin typeface="Calibri"/>
+              </a:rPr>
+              <a:t>No install, no server — open one HTML file.</a:t>
+            </a:r>
+          </a:p>
+          <a:p>
+            <a:pPr algn="l">
+              <a:spcBef>
+                <a:spcPts val="0"/>
+              </a:spcBef>
+              <a:spcAft>
+                <a:spcPts val="1200"/>
+              </a:spcAft>
+            </a:pPr>
+            <a:r>
+              <a:rPr sz="1450" b="0" i="0">
+                <a:solidFill>
+                  <a:srgbClr val="DDE7EA"/>
+                </a:solidFill>
+                <a:latin typeface="Calibri"/>
+              </a:rPr>
+              <a:t>Decisions saved locally; export to CSV/JSON.</a:t>
+            </a:r>
+          </a:p>
+          <a:p>
+            <a:pPr algn="l">
+              <a:spcBef>
+                <a:spcPts val="0"/>
+              </a:spcBef>
+              <a:spcAft>
+                <a:spcPts val="1200"/>
+              </a:spcAft>
+            </a:pPr>
+            <a:r>
+              <a:rPr sz="1450" b="0" i="0">
+                <a:solidFill>
+                  <a:srgbClr val="DDE7EA"/>
+                </a:solidFill>
+                <a:latin typeface="Calibri"/>
+              </a:rPr>
+              <a:t>Re-includes even discarded edges, so you keep full control.</a:t>
+            </a:r>
+          </a:p>
+          <a:p>
+            <a:pPr algn="l">
+              <a:spcBef>
+                <a:spcPts val="0"/>
+              </a:spcBef>
+              <a:spcAft>
+                <a:spcPts val="1200"/>
+              </a:spcAft>
+            </a:pPr>
+            <a:r>
+              <a:rPr sz="1450" b="0" i="0">
+                <a:solidFill>
+                  <a:srgbClr val="DDE7EA"/>
+                </a:solidFill>
+                <a:latin typeface="Calibri"/>
+              </a:rPr>
+              <a:t>Demo right after this.</a:t>
+            </a:r>
+          </a:p>
+        </p:txBody>
+      </p:sp>
+      <p:sp>
+        <p:nvSpPr>
+          <p:cNvPr id="9" name="TextBox 8"/>
           <p:cNvSpPr txBox="1"/>
           <p:nvPr/>
         </p:nvSpPr>
         <p:spPr>
           <a:xfrm>
-            <a:off x="4608576" y="2971800"/>
-            <a:ext cx="3063240" cy="2468880"/>
+            <a:off x="548640" y="6437376"/>
+            <a:ext cx="8229600" cy="365760"/>
           </a:xfrm>
           <a:prstGeom prst="rect">
             <a:avLst/>
@@ -8849,280 +9412,10 @@
                 <a:spcPts val="0"/>
               </a:spcBef>
               <a:spcAft>
-                <a:spcPts val="800"/>
-              </a:spcAft>
-            </a:pPr>
-            <a:r>
-              <a:rPr sz="1800" b="1" i="0">
-                <a:solidFill>
-                  <a:srgbClr val="142C3A"/>
-                </a:solidFill>
-                <a:latin typeface="Calibri"/>
-              </a:rPr>
-              <a:t>Curate the entities</a:t>
-            </a:r>
-          </a:p>
-          <a:p>
-            <a:pPr algn="l">
-              <a:spcBef>
-                <a:spcPts val="0"/>
-              </a:spcBef>
-              <a:spcAft>
                 <a:spcPts val="600"/>
               </a:spcAft>
             </a:pPr>
             <a:r>
-              <a:rPr sz="1450" b="0" i="0">
-                <a:solidFill>
-                  <a:srgbClr val="223038"/>
-                </a:solidFill>
-                <a:latin typeface="Calibri"/>
-              </a:rPr>
-              <a:t>Tier-1 SSc species: what to add, remove, or promote — with PMIDs where you have them.</a:t>
-            </a:r>
-          </a:p>
-        </p:txBody>
-      </p:sp>
-      <p:sp>
-        <p:nvSpPr>
-          <p:cNvPr id="14" name="Rectangle 13"/>
-          <p:cNvSpPr/>
-          <p:nvPr/>
-        </p:nvSpPr>
-        <p:spPr>
-          <a:xfrm>
-            <a:off x="8083296" y="1554480"/>
-            <a:ext cx="3611880" cy="4023360"/>
-          </a:xfrm>
-          <a:prstGeom prst="rect">
-            <a:avLst/>
-          </a:prstGeom>
-          <a:solidFill>
-            <a:srgbClr val="FFFFFF"/>
-          </a:solidFill>
-          <a:ln>
-            <a:noFill/>
-          </a:ln>
-          <a:effectLst/>
-        </p:spPr>
-        <p:style>
-          <a:lnRef idx="1">
-            <a:schemeClr val="accent1"/>
-          </a:lnRef>
-          <a:fillRef idx="3">
-            <a:schemeClr val="accent1"/>
-          </a:fillRef>
-          <a:effectRef idx="2">
-            <a:schemeClr val="accent1"/>
-          </a:effectRef>
-          <a:fontRef idx="minor">
-            <a:schemeClr val="lt1"/>
-          </a:fontRef>
-        </p:style>
-        <p:txBody>
-          <a:bodyPr rtlCol="0" anchor="ctr"/>
-          <a:lstStyle/>
-          <a:p>
-            <a:pPr algn="ctr"/>
-          </a:p>
-        </p:txBody>
-      </p:sp>
-      <p:sp>
-        <p:nvSpPr>
-          <p:cNvPr id="15" name="Rectangle 14"/>
-          <p:cNvSpPr/>
-          <p:nvPr/>
-        </p:nvSpPr>
-        <p:spPr>
-          <a:xfrm>
-            <a:off x="8083296" y="1554480"/>
-            <a:ext cx="3611880" cy="82296"/>
-          </a:xfrm>
-          <a:prstGeom prst="rect">
-            <a:avLst/>
-          </a:prstGeom>
-          <a:solidFill>
-            <a:srgbClr val="3F9E8C"/>
-          </a:solidFill>
-          <a:ln>
-            <a:noFill/>
-          </a:ln>
-          <a:effectLst/>
-        </p:spPr>
-        <p:style>
-          <a:lnRef idx="1">
-            <a:schemeClr val="accent1"/>
-          </a:lnRef>
-          <a:fillRef idx="3">
-            <a:schemeClr val="accent1"/>
-          </a:fillRef>
-          <a:effectRef idx="2">
-            <a:schemeClr val="accent1"/>
-          </a:effectRef>
-          <a:fontRef idx="minor">
-            <a:schemeClr val="lt1"/>
-          </a:fontRef>
-        </p:style>
-        <p:txBody>
-          <a:bodyPr rtlCol="0" anchor="ctr"/>
-          <a:lstStyle/>
-          <a:p>
-            <a:pPr algn="ctr"/>
-          </a:p>
-        </p:txBody>
-      </p:sp>
-      <p:sp>
-        <p:nvSpPr>
-          <p:cNvPr id="16" name="Oval 15"/>
-          <p:cNvSpPr/>
-          <p:nvPr/>
-        </p:nvSpPr>
-        <p:spPr>
-          <a:xfrm>
-            <a:off x="8357616" y="1874519"/>
-            <a:ext cx="868680" cy="868680"/>
-          </a:xfrm>
-          <a:prstGeom prst="ellipse">
-            <a:avLst/>
-          </a:prstGeom>
-          <a:solidFill>
-            <a:srgbClr val="3F9E8C"/>
-          </a:solidFill>
-          <a:ln>
-            <a:noFill/>
-          </a:ln>
-          <a:effectLst/>
-        </p:spPr>
-        <p:style>
-          <a:lnRef idx="1">
-            <a:schemeClr val="accent1"/>
-          </a:lnRef>
-          <a:fillRef idx="3">
-            <a:schemeClr val="accent1"/>
-          </a:fillRef>
-          <a:effectRef idx="2">
-            <a:schemeClr val="accent1"/>
-          </a:effectRef>
-          <a:fontRef idx="minor">
-            <a:schemeClr val="lt1"/>
-          </a:fontRef>
-        </p:style>
-        <p:txBody>
-          <a:bodyPr rtlCol="0" anchor="ctr"/>
-          <a:lstStyle/>
-          <a:p>
-            <a:pPr algn="ctr">
-              <a:spcBef>
-                <a:spcPts val="0"/>
-              </a:spcBef>
-              <a:spcAft>
-                <a:spcPts val="600"/>
-              </a:spcAft>
-            </a:pPr>
-            <a:r>
-              <a:rPr sz="2800" b="1" i="0">
-                <a:solidFill>
-                  <a:srgbClr val="FFFFFF"/>
-                </a:solidFill>
-                <a:latin typeface="Calibri"/>
-              </a:rPr>
-              <a:t>3</a:t>
-            </a:r>
-          </a:p>
-        </p:txBody>
-      </p:sp>
-      <p:sp>
-        <p:nvSpPr>
-          <p:cNvPr id="17" name="TextBox 16"/>
-          <p:cNvSpPr txBox="1"/>
-          <p:nvPr/>
-        </p:nvSpPr>
-        <p:spPr>
-          <a:xfrm>
-            <a:off x="8375904" y="2971800"/>
-            <a:ext cx="3063240" cy="2468880"/>
-          </a:xfrm>
-          <a:prstGeom prst="rect">
-            <a:avLst/>
-          </a:prstGeom>
-          <a:noFill/>
-        </p:spPr>
-        <p:txBody>
-          <a:bodyPr wrap="square">
-            <a:spAutoFit/>
-          </a:bodyPr>
-          <a:lstStyle/>
-          <a:p>
-            <a:pPr algn="l">
-              <a:spcBef>
-                <a:spcPts val="0"/>
-              </a:spcBef>
-              <a:spcAft>
-                <a:spcPts val="800"/>
-              </a:spcAft>
-            </a:pPr>
-            <a:r>
-              <a:rPr sz="1800" b="1" i="0">
-                <a:solidFill>
-                  <a:srgbClr val="142C3A"/>
-                </a:solidFill>
-                <a:latin typeface="Calibri"/>
-              </a:rPr>
-              <a:t>Adjudicate interactions</a:t>
-            </a:r>
-          </a:p>
-          <a:p>
-            <a:pPr algn="l">
-              <a:spcBef>
-                <a:spcPts val="0"/>
-              </a:spcBef>
-              <a:spcAft>
-                <a:spcPts val="600"/>
-              </a:spcAft>
-            </a:pPr>
-            <a:r>
-              <a:rPr sz="1450" b="0" i="0">
-                <a:solidFill>
-                  <a:srgbClr val="223038"/>
-                </a:solidFill>
-                <a:latin typeface="Calibri"/>
-              </a:rPr>
-              <a:t>Use the review app on the 143 interactions: confirm, reject, or flag for revision.</a:t>
-            </a:r>
-          </a:p>
-        </p:txBody>
-      </p:sp>
-      <p:sp>
-        <p:nvSpPr>
-          <p:cNvPr id="18" name="TextBox 17"/>
-          <p:cNvSpPr txBox="1"/>
-          <p:nvPr/>
-        </p:nvSpPr>
-        <p:spPr>
-          <a:xfrm>
-            <a:off x="548640" y="6437376"/>
-            <a:ext cx="8229600" cy="365760"/>
-          </a:xfrm>
-          <a:prstGeom prst="rect">
-            <a:avLst/>
-          </a:prstGeom>
-          <a:noFill/>
-        </p:spPr>
-        <p:txBody>
-          <a:bodyPr wrap="square">
-            <a:spAutoFit/>
-          </a:bodyPr>
-          <a:lstStyle/>
-          <a:p>
-            <a:pPr algn="l">
-              <a:spcBef>
-                <a:spcPts val="0"/>
-              </a:spcBef>
-              <a:spcAft>
-                <a:spcPts val="600"/>
-              </a:spcAft>
-            </a:pPr>
-            <a:r>
               <a:rPr sz="900" b="0" i="0">
                 <a:solidFill>
                   <a:srgbClr val="6B7A82"/>
@@ -9136,7 +9429,7 @@
       </p:sp>
       <p:sp>
         <p:nvSpPr>
-          <p:cNvPr id="19" name="TextBox 18"/>
+          <p:cNvPr id="10" name="TextBox 9"/>
           <p:cNvSpPr txBox="1"/>
           <p:nvPr/>
         </p:nvSpPr>
@@ -9185,6 +9478,928 @@
 </file>
 
 <file path=ppt/slides/slide17.xml><?xml version="1.0" encoding="utf-8"?>
+<p:sld xmlns:a="http://schemas.openxmlformats.org/drawingml/2006/main" xmlns:p="http://schemas.openxmlformats.org/presentationml/2006/main" xmlns:r="http://schemas.openxmlformats.org/officeDocument/2006/relationships">
+  <p:cSld>
+    <p:spTree>
+      <p:nvGrpSpPr>
+        <p:cNvPr id="1" name=""/>
+        <p:cNvGrpSpPr/>
+        <p:nvPr/>
+      </p:nvGrpSpPr>
+      <p:grpSpPr/>
+      <p:sp>
+        <p:nvSpPr>
+          <p:cNvPr id="2" name="Rectangle 1"/>
+          <p:cNvSpPr/>
+          <p:nvPr/>
+        </p:nvSpPr>
+        <p:spPr>
+          <a:xfrm>
+            <a:off x="0" y="0"/>
+            <a:ext cx="12191695" cy="6858000"/>
+          </a:xfrm>
+          <a:prstGeom prst="rect">
+            <a:avLst/>
+          </a:prstGeom>
+          <a:solidFill>
+            <a:srgbClr val="F6F4F0"/>
+          </a:solidFill>
+          <a:ln>
+            <a:noFill/>
+          </a:ln>
+          <a:effectLst/>
+        </p:spPr>
+        <p:style>
+          <a:lnRef idx="1">
+            <a:schemeClr val="accent1"/>
+          </a:lnRef>
+          <a:fillRef idx="3">
+            <a:schemeClr val="accent1"/>
+          </a:fillRef>
+          <a:effectRef idx="2">
+            <a:schemeClr val="accent1"/>
+          </a:effectRef>
+          <a:fontRef idx="minor">
+            <a:schemeClr val="lt1"/>
+          </a:fontRef>
+        </p:style>
+        <p:txBody>
+          <a:bodyPr rtlCol="0" anchor="ctr"/>
+          <a:lstStyle/>
+          <a:p>
+            <a:pPr algn="ctr"/>
+          </a:p>
+        </p:txBody>
+      </p:sp>
+      <p:sp>
+        <p:nvSpPr>
+          <p:cNvPr id="3" name="Rectangle 2"/>
+          <p:cNvSpPr/>
+          <p:nvPr/>
+        </p:nvSpPr>
+        <p:spPr>
+          <a:xfrm>
+            <a:off x="0" y="0"/>
+            <a:ext cx="12191695" cy="1078992"/>
+          </a:xfrm>
+          <a:prstGeom prst="rect">
+            <a:avLst/>
+          </a:prstGeom>
+          <a:solidFill>
+            <a:srgbClr val="142C3A"/>
+          </a:solidFill>
+          <a:ln>
+            <a:noFill/>
+          </a:ln>
+          <a:effectLst/>
+        </p:spPr>
+        <p:style>
+          <a:lnRef idx="1">
+            <a:schemeClr val="accent1"/>
+          </a:lnRef>
+          <a:fillRef idx="3">
+            <a:schemeClr val="accent1"/>
+          </a:fillRef>
+          <a:effectRef idx="2">
+            <a:schemeClr val="accent1"/>
+          </a:effectRef>
+          <a:fontRef idx="minor">
+            <a:schemeClr val="lt1"/>
+          </a:fontRef>
+        </p:style>
+        <p:txBody>
+          <a:bodyPr rtlCol="0" anchor="ctr"/>
+          <a:lstStyle/>
+          <a:p>
+            <a:pPr algn="ctr"/>
+          </a:p>
+        </p:txBody>
+      </p:sp>
+      <p:sp>
+        <p:nvSpPr>
+          <p:cNvPr id="4" name="Rectangle 3"/>
+          <p:cNvSpPr/>
+          <p:nvPr/>
+        </p:nvSpPr>
+        <p:spPr>
+          <a:xfrm>
+            <a:off x="0" y="1078992"/>
+            <a:ext cx="12191695" cy="54864"/>
+          </a:xfrm>
+          <a:prstGeom prst="rect">
+            <a:avLst/>
+          </a:prstGeom>
+          <a:solidFill>
+            <a:srgbClr val="E26D5A"/>
+          </a:solidFill>
+          <a:ln>
+            <a:noFill/>
+          </a:ln>
+          <a:effectLst/>
+        </p:spPr>
+        <p:style>
+          <a:lnRef idx="1">
+            <a:schemeClr val="accent1"/>
+          </a:lnRef>
+          <a:fillRef idx="3">
+            <a:schemeClr val="accent1"/>
+          </a:fillRef>
+          <a:effectRef idx="2">
+            <a:schemeClr val="accent1"/>
+          </a:effectRef>
+          <a:fontRef idx="minor">
+            <a:schemeClr val="lt1"/>
+          </a:fontRef>
+        </p:style>
+        <p:txBody>
+          <a:bodyPr rtlCol="0" anchor="ctr"/>
+          <a:lstStyle/>
+          <a:p>
+            <a:pPr algn="ctr"/>
+          </a:p>
+        </p:txBody>
+      </p:sp>
+      <p:sp>
+        <p:nvSpPr>
+          <p:cNvPr id="5" name="TextBox 4"/>
+          <p:cNvSpPr txBox="1"/>
+          <p:nvPr/>
+        </p:nvSpPr>
+        <p:spPr>
+          <a:xfrm>
+            <a:off x="548640" y="109728"/>
+            <a:ext cx="11155680" cy="914400"/>
+          </a:xfrm>
+          <a:prstGeom prst="rect">
+            <a:avLst/>
+          </a:prstGeom>
+          <a:noFill/>
+        </p:spPr>
+        <p:txBody>
+          <a:bodyPr wrap="square">
+            <a:spAutoFit/>
+          </a:bodyPr>
+          <a:lstStyle/>
+          <a:p>
+            <a:pPr algn="l">
+              <a:spcBef>
+                <a:spcPts val="0"/>
+              </a:spcBef>
+              <a:spcAft>
+                <a:spcPts val="600"/>
+              </a:spcAft>
+            </a:pPr>
+            <a:r>
+              <a:rPr sz="1200" b="1" i="0">
+                <a:solidFill>
+                  <a:srgbClr val="E26D5A"/>
+                </a:solidFill>
+                <a:latin typeface="Calibri"/>
+              </a:rPr>
+              <a:t>WHAT WE ASK OF YOU</a:t>
+            </a:r>
+          </a:p>
+          <a:p>
+            <a:pPr algn="l">
+              <a:spcBef>
+                <a:spcPts val="100"/>
+              </a:spcBef>
+              <a:spcAft>
+                <a:spcPts val="600"/>
+              </a:spcAft>
+            </a:pPr>
+            <a:r>
+              <a:rPr sz="2500" b="1" i="0">
+                <a:solidFill>
+                  <a:srgbClr val="FFFFFF"/>
+                </a:solidFill>
+                <a:latin typeface="Calibri"/>
+              </a:rPr>
+              <a:t>Three things from expert biologists</a:t>
+            </a:r>
+          </a:p>
+        </p:txBody>
+      </p:sp>
+      <p:sp>
+        <p:nvSpPr>
+          <p:cNvPr id="6" name="Rectangle 5"/>
+          <p:cNvSpPr/>
+          <p:nvPr/>
+        </p:nvSpPr>
+        <p:spPr>
+          <a:xfrm>
+            <a:off x="548640" y="1554480"/>
+            <a:ext cx="3611880" cy="4023360"/>
+          </a:xfrm>
+          <a:prstGeom prst="rect">
+            <a:avLst/>
+          </a:prstGeom>
+          <a:solidFill>
+            <a:srgbClr val="FFFFFF"/>
+          </a:solidFill>
+          <a:ln>
+            <a:noFill/>
+          </a:ln>
+          <a:effectLst/>
+        </p:spPr>
+        <p:style>
+          <a:lnRef idx="1">
+            <a:schemeClr val="accent1"/>
+          </a:lnRef>
+          <a:fillRef idx="3">
+            <a:schemeClr val="accent1"/>
+          </a:fillRef>
+          <a:effectRef idx="2">
+            <a:schemeClr val="accent1"/>
+          </a:effectRef>
+          <a:fontRef idx="minor">
+            <a:schemeClr val="lt1"/>
+          </a:fontRef>
+        </p:style>
+        <p:txBody>
+          <a:bodyPr rtlCol="0" anchor="ctr"/>
+          <a:lstStyle/>
+          <a:p>
+            <a:pPr algn="ctr"/>
+          </a:p>
+        </p:txBody>
+      </p:sp>
+      <p:sp>
+        <p:nvSpPr>
+          <p:cNvPr id="7" name="Rectangle 6"/>
+          <p:cNvSpPr/>
+          <p:nvPr/>
+        </p:nvSpPr>
+        <p:spPr>
+          <a:xfrm>
+            <a:off x="548640" y="1554480"/>
+            <a:ext cx="3611880" cy="82296"/>
+          </a:xfrm>
+          <a:prstGeom prst="rect">
+            <a:avLst/>
+          </a:prstGeom>
+          <a:solidFill>
+            <a:srgbClr val="3A73B8"/>
+          </a:solidFill>
+          <a:ln>
+            <a:noFill/>
+          </a:ln>
+          <a:effectLst/>
+        </p:spPr>
+        <p:style>
+          <a:lnRef idx="1">
+            <a:schemeClr val="accent1"/>
+          </a:lnRef>
+          <a:fillRef idx="3">
+            <a:schemeClr val="accent1"/>
+          </a:fillRef>
+          <a:effectRef idx="2">
+            <a:schemeClr val="accent1"/>
+          </a:effectRef>
+          <a:fontRef idx="minor">
+            <a:schemeClr val="lt1"/>
+          </a:fontRef>
+        </p:style>
+        <p:txBody>
+          <a:bodyPr rtlCol="0" anchor="ctr"/>
+          <a:lstStyle/>
+          <a:p>
+            <a:pPr algn="ctr"/>
+          </a:p>
+        </p:txBody>
+      </p:sp>
+      <p:sp>
+        <p:nvSpPr>
+          <p:cNvPr id="8" name="Oval 7"/>
+          <p:cNvSpPr/>
+          <p:nvPr/>
+        </p:nvSpPr>
+        <p:spPr>
+          <a:xfrm>
+            <a:off x="822959" y="1874519"/>
+            <a:ext cx="868680" cy="868680"/>
+          </a:xfrm>
+          <a:prstGeom prst="ellipse">
+            <a:avLst/>
+          </a:prstGeom>
+          <a:solidFill>
+            <a:srgbClr val="3A73B8"/>
+          </a:solidFill>
+          <a:ln>
+            <a:noFill/>
+          </a:ln>
+          <a:effectLst/>
+        </p:spPr>
+        <p:style>
+          <a:lnRef idx="1">
+            <a:schemeClr val="accent1"/>
+          </a:lnRef>
+          <a:fillRef idx="3">
+            <a:schemeClr val="accent1"/>
+          </a:fillRef>
+          <a:effectRef idx="2">
+            <a:schemeClr val="accent1"/>
+          </a:effectRef>
+          <a:fontRef idx="minor">
+            <a:schemeClr val="lt1"/>
+          </a:fontRef>
+        </p:style>
+        <p:txBody>
+          <a:bodyPr rtlCol="0" anchor="ctr"/>
+          <a:lstStyle/>
+          <a:p>
+            <a:pPr algn="ctr">
+              <a:spcBef>
+                <a:spcPts val="0"/>
+              </a:spcBef>
+              <a:spcAft>
+                <a:spcPts val="600"/>
+              </a:spcAft>
+            </a:pPr>
+            <a:r>
+              <a:rPr sz="2800" b="1" i="0">
+                <a:solidFill>
+                  <a:srgbClr val="FFFFFF"/>
+                </a:solidFill>
+                <a:latin typeface="Calibri"/>
+              </a:rPr>
+              <a:t>1</a:t>
+            </a:r>
+          </a:p>
+        </p:txBody>
+      </p:sp>
+      <p:sp>
+        <p:nvSpPr>
+          <p:cNvPr id="9" name="TextBox 8"/>
+          <p:cNvSpPr txBox="1"/>
+          <p:nvPr/>
+        </p:nvSpPr>
+        <p:spPr>
+          <a:xfrm>
+            <a:off x="841247" y="2971800"/>
+            <a:ext cx="3063240" cy="2468880"/>
+          </a:xfrm>
+          <a:prstGeom prst="rect">
+            <a:avLst/>
+          </a:prstGeom>
+          <a:noFill/>
+        </p:spPr>
+        <p:txBody>
+          <a:bodyPr wrap="square">
+            <a:spAutoFit/>
+          </a:bodyPr>
+          <a:lstStyle/>
+          <a:p>
+            <a:pPr algn="l">
+              <a:spcBef>
+                <a:spcPts val="0"/>
+              </a:spcBef>
+              <a:spcAft>
+                <a:spcPts val="800"/>
+              </a:spcAft>
+            </a:pPr>
+            <a:r>
+              <a:rPr sz="1800" b="1" i="0">
+                <a:solidFill>
+                  <a:srgbClr val="142C3A"/>
+                </a:solidFill>
+                <a:latin typeface="Calibri"/>
+              </a:rPr>
+              <a:t>Validate the scope</a:t>
+            </a:r>
+          </a:p>
+          <a:p>
+            <a:pPr algn="l">
+              <a:spcBef>
+                <a:spcPts val="0"/>
+              </a:spcBef>
+              <a:spcAft>
+                <a:spcPts val="600"/>
+              </a:spcAft>
+            </a:pPr>
+            <a:r>
+              <a:rPr sz="1450" b="0" i="0">
+                <a:solidFill>
+                  <a:srgbClr val="223038"/>
+                </a:solidFill>
+                <a:latin typeface="Calibri"/>
+              </a:rPr>
+              <a:t>Do the 4 modules + phenotype sinks capture dcSSc skin fibrosis? What is missing or over-reaching?</a:t>
+            </a:r>
+          </a:p>
+        </p:txBody>
+      </p:sp>
+      <p:sp>
+        <p:nvSpPr>
+          <p:cNvPr id="10" name="Rectangle 9"/>
+          <p:cNvSpPr/>
+          <p:nvPr/>
+        </p:nvSpPr>
+        <p:spPr>
+          <a:xfrm>
+            <a:off x="4315968" y="1554480"/>
+            <a:ext cx="3611880" cy="4023360"/>
+          </a:xfrm>
+          <a:prstGeom prst="rect">
+            <a:avLst/>
+          </a:prstGeom>
+          <a:solidFill>
+            <a:srgbClr val="FFFFFF"/>
+          </a:solidFill>
+          <a:ln>
+            <a:noFill/>
+          </a:ln>
+          <a:effectLst/>
+        </p:spPr>
+        <p:style>
+          <a:lnRef idx="1">
+            <a:schemeClr val="accent1"/>
+          </a:lnRef>
+          <a:fillRef idx="3">
+            <a:schemeClr val="accent1"/>
+          </a:fillRef>
+          <a:effectRef idx="2">
+            <a:schemeClr val="accent1"/>
+          </a:effectRef>
+          <a:fontRef idx="minor">
+            <a:schemeClr val="lt1"/>
+          </a:fontRef>
+        </p:style>
+        <p:txBody>
+          <a:bodyPr rtlCol="0" anchor="ctr"/>
+          <a:lstStyle/>
+          <a:p>
+            <a:pPr algn="ctr"/>
+          </a:p>
+        </p:txBody>
+      </p:sp>
+      <p:sp>
+        <p:nvSpPr>
+          <p:cNvPr id="11" name="Rectangle 10"/>
+          <p:cNvSpPr/>
+          <p:nvPr/>
+        </p:nvSpPr>
+        <p:spPr>
+          <a:xfrm>
+            <a:off x="4315968" y="1554480"/>
+            <a:ext cx="3611880" cy="82296"/>
+          </a:xfrm>
+          <a:prstGeom prst="rect">
+            <a:avLst/>
+          </a:prstGeom>
+          <a:solidFill>
+            <a:srgbClr val="E26D5A"/>
+          </a:solidFill>
+          <a:ln>
+            <a:noFill/>
+          </a:ln>
+          <a:effectLst/>
+        </p:spPr>
+        <p:style>
+          <a:lnRef idx="1">
+            <a:schemeClr val="accent1"/>
+          </a:lnRef>
+          <a:fillRef idx="3">
+            <a:schemeClr val="accent1"/>
+          </a:fillRef>
+          <a:effectRef idx="2">
+            <a:schemeClr val="accent1"/>
+          </a:effectRef>
+          <a:fontRef idx="minor">
+            <a:schemeClr val="lt1"/>
+          </a:fontRef>
+        </p:style>
+        <p:txBody>
+          <a:bodyPr rtlCol="0" anchor="ctr"/>
+          <a:lstStyle/>
+          <a:p>
+            <a:pPr algn="ctr"/>
+          </a:p>
+        </p:txBody>
+      </p:sp>
+      <p:sp>
+        <p:nvSpPr>
+          <p:cNvPr id="12" name="Oval 11"/>
+          <p:cNvSpPr/>
+          <p:nvPr/>
+        </p:nvSpPr>
+        <p:spPr>
+          <a:xfrm>
+            <a:off x="4590288" y="1874519"/>
+            <a:ext cx="868680" cy="868680"/>
+          </a:xfrm>
+          <a:prstGeom prst="ellipse">
+            <a:avLst/>
+          </a:prstGeom>
+          <a:solidFill>
+            <a:srgbClr val="E26D5A"/>
+          </a:solidFill>
+          <a:ln>
+            <a:noFill/>
+          </a:ln>
+          <a:effectLst/>
+        </p:spPr>
+        <p:style>
+          <a:lnRef idx="1">
+            <a:schemeClr val="accent1"/>
+          </a:lnRef>
+          <a:fillRef idx="3">
+            <a:schemeClr val="accent1"/>
+          </a:fillRef>
+          <a:effectRef idx="2">
+            <a:schemeClr val="accent1"/>
+          </a:effectRef>
+          <a:fontRef idx="minor">
+            <a:schemeClr val="lt1"/>
+          </a:fontRef>
+        </p:style>
+        <p:txBody>
+          <a:bodyPr rtlCol="0" anchor="ctr"/>
+          <a:lstStyle/>
+          <a:p>
+            <a:pPr algn="ctr">
+              <a:spcBef>
+                <a:spcPts val="0"/>
+              </a:spcBef>
+              <a:spcAft>
+                <a:spcPts val="600"/>
+              </a:spcAft>
+            </a:pPr>
+            <a:r>
+              <a:rPr sz="2800" b="1" i="0">
+                <a:solidFill>
+                  <a:srgbClr val="FFFFFF"/>
+                </a:solidFill>
+                <a:latin typeface="Calibri"/>
+              </a:rPr>
+              <a:t>2</a:t>
+            </a:r>
+          </a:p>
+        </p:txBody>
+      </p:sp>
+      <p:sp>
+        <p:nvSpPr>
+          <p:cNvPr id="13" name="TextBox 12"/>
+          <p:cNvSpPr txBox="1"/>
+          <p:nvPr/>
+        </p:nvSpPr>
+        <p:spPr>
+          <a:xfrm>
+            <a:off x="4608576" y="2971800"/>
+            <a:ext cx="3063240" cy="2468880"/>
+          </a:xfrm>
+          <a:prstGeom prst="rect">
+            <a:avLst/>
+          </a:prstGeom>
+          <a:noFill/>
+        </p:spPr>
+        <p:txBody>
+          <a:bodyPr wrap="square">
+            <a:spAutoFit/>
+          </a:bodyPr>
+          <a:lstStyle/>
+          <a:p>
+            <a:pPr algn="l">
+              <a:spcBef>
+                <a:spcPts val="0"/>
+              </a:spcBef>
+              <a:spcAft>
+                <a:spcPts val="800"/>
+              </a:spcAft>
+            </a:pPr>
+            <a:r>
+              <a:rPr sz="1800" b="1" i="0">
+                <a:solidFill>
+                  <a:srgbClr val="142C3A"/>
+                </a:solidFill>
+                <a:latin typeface="Calibri"/>
+              </a:rPr>
+              <a:t>Curate the entities</a:t>
+            </a:r>
+          </a:p>
+          <a:p>
+            <a:pPr algn="l">
+              <a:spcBef>
+                <a:spcPts val="0"/>
+              </a:spcBef>
+              <a:spcAft>
+                <a:spcPts val="600"/>
+              </a:spcAft>
+            </a:pPr>
+            <a:r>
+              <a:rPr sz="1450" b="0" i="0">
+                <a:solidFill>
+                  <a:srgbClr val="223038"/>
+                </a:solidFill>
+                <a:latin typeface="Calibri"/>
+              </a:rPr>
+              <a:t>Tier-1 SSc species: what to add, remove, or promote — with PMIDs where you have them.</a:t>
+            </a:r>
+          </a:p>
+        </p:txBody>
+      </p:sp>
+      <p:sp>
+        <p:nvSpPr>
+          <p:cNvPr id="14" name="Rectangle 13"/>
+          <p:cNvSpPr/>
+          <p:nvPr/>
+        </p:nvSpPr>
+        <p:spPr>
+          <a:xfrm>
+            <a:off x="8083296" y="1554480"/>
+            <a:ext cx="3611880" cy="4023360"/>
+          </a:xfrm>
+          <a:prstGeom prst="rect">
+            <a:avLst/>
+          </a:prstGeom>
+          <a:solidFill>
+            <a:srgbClr val="FFFFFF"/>
+          </a:solidFill>
+          <a:ln>
+            <a:noFill/>
+          </a:ln>
+          <a:effectLst/>
+        </p:spPr>
+        <p:style>
+          <a:lnRef idx="1">
+            <a:schemeClr val="accent1"/>
+          </a:lnRef>
+          <a:fillRef idx="3">
+            <a:schemeClr val="accent1"/>
+          </a:fillRef>
+          <a:effectRef idx="2">
+            <a:schemeClr val="accent1"/>
+          </a:effectRef>
+          <a:fontRef idx="minor">
+            <a:schemeClr val="lt1"/>
+          </a:fontRef>
+        </p:style>
+        <p:txBody>
+          <a:bodyPr rtlCol="0" anchor="ctr"/>
+          <a:lstStyle/>
+          <a:p>
+            <a:pPr algn="ctr"/>
+          </a:p>
+        </p:txBody>
+      </p:sp>
+      <p:sp>
+        <p:nvSpPr>
+          <p:cNvPr id="15" name="Rectangle 14"/>
+          <p:cNvSpPr/>
+          <p:nvPr/>
+        </p:nvSpPr>
+        <p:spPr>
+          <a:xfrm>
+            <a:off x="8083296" y="1554480"/>
+            <a:ext cx="3611880" cy="82296"/>
+          </a:xfrm>
+          <a:prstGeom prst="rect">
+            <a:avLst/>
+          </a:prstGeom>
+          <a:solidFill>
+            <a:srgbClr val="3F9E8C"/>
+          </a:solidFill>
+          <a:ln>
+            <a:noFill/>
+          </a:ln>
+          <a:effectLst/>
+        </p:spPr>
+        <p:style>
+          <a:lnRef idx="1">
+            <a:schemeClr val="accent1"/>
+          </a:lnRef>
+          <a:fillRef idx="3">
+            <a:schemeClr val="accent1"/>
+          </a:fillRef>
+          <a:effectRef idx="2">
+            <a:schemeClr val="accent1"/>
+          </a:effectRef>
+          <a:fontRef idx="minor">
+            <a:schemeClr val="lt1"/>
+          </a:fontRef>
+        </p:style>
+        <p:txBody>
+          <a:bodyPr rtlCol="0" anchor="ctr"/>
+          <a:lstStyle/>
+          <a:p>
+            <a:pPr algn="ctr"/>
+          </a:p>
+        </p:txBody>
+      </p:sp>
+      <p:sp>
+        <p:nvSpPr>
+          <p:cNvPr id="16" name="Oval 15"/>
+          <p:cNvSpPr/>
+          <p:nvPr/>
+        </p:nvSpPr>
+        <p:spPr>
+          <a:xfrm>
+            <a:off x="8357616" y="1874519"/>
+            <a:ext cx="868680" cy="868680"/>
+          </a:xfrm>
+          <a:prstGeom prst="ellipse">
+            <a:avLst/>
+          </a:prstGeom>
+          <a:solidFill>
+            <a:srgbClr val="3F9E8C"/>
+          </a:solidFill>
+          <a:ln>
+            <a:noFill/>
+          </a:ln>
+          <a:effectLst/>
+        </p:spPr>
+        <p:style>
+          <a:lnRef idx="1">
+            <a:schemeClr val="accent1"/>
+          </a:lnRef>
+          <a:fillRef idx="3">
+            <a:schemeClr val="accent1"/>
+          </a:fillRef>
+          <a:effectRef idx="2">
+            <a:schemeClr val="accent1"/>
+          </a:effectRef>
+          <a:fontRef idx="minor">
+            <a:schemeClr val="lt1"/>
+          </a:fontRef>
+        </p:style>
+        <p:txBody>
+          <a:bodyPr rtlCol="0" anchor="ctr"/>
+          <a:lstStyle/>
+          <a:p>
+            <a:pPr algn="ctr">
+              <a:spcBef>
+                <a:spcPts val="0"/>
+              </a:spcBef>
+              <a:spcAft>
+                <a:spcPts val="600"/>
+              </a:spcAft>
+            </a:pPr>
+            <a:r>
+              <a:rPr sz="2800" b="1" i="0">
+                <a:solidFill>
+                  <a:srgbClr val="FFFFFF"/>
+                </a:solidFill>
+                <a:latin typeface="Calibri"/>
+              </a:rPr>
+              <a:t>3</a:t>
+            </a:r>
+          </a:p>
+        </p:txBody>
+      </p:sp>
+      <p:sp>
+        <p:nvSpPr>
+          <p:cNvPr id="17" name="TextBox 16"/>
+          <p:cNvSpPr txBox="1"/>
+          <p:nvPr/>
+        </p:nvSpPr>
+        <p:spPr>
+          <a:xfrm>
+            <a:off x="8375904" y="2971800"/>
+            <a:ext cx="3063240" cy="2468880"/>
+          </a:xfrm>
+          <a:prstGeom prst="rect">
+            <a:avLst/>
+          </a:prstGeom>
+          <a:noFill/>
+        </p:spPr>
+        <p:txBody>
+          <a:bodyPr wrap="square">
+            <a:spAutoFit/>
+          </a:bodyPr>
+          <a:lstStyle/>
+          <a:p>
+            <a:pPr algn="l">
+              <a:spcBef>
+                <a:spcPts val="0"/>
+              </a:spcBef>
+              <a:spcAft>
+                <a:spcPts val="800"/>
+              </a:spcAft>
+            </a:pPr>
+            <a:r>
+              <a:rPr sz="1800" b="1" i="0">
+                <a:solidFill>
+                  <a:srgbClr val="142C3A"/>
+                </a:solidFill>
+                <a:latin typeface="Calibri"/>
+              </a:rPr>
+              <a:t>Adjudicate interactions</a:t>
+            </a:r>
+          </a:p>
+          <a:p>
+            <a:pPr algn="l">
+              <a:spcBef>
+                <a:spcPts val="0"/>
+              </a:spcBef>
+              <a:spcAft>
+                <a:spcPts val="600"/>
+              </a:spcAft>
+            </a:pPr>
+            <a:r>
+              <a:rPr sz="1450" b="0" i="0">
+                <a:solidFill>
+                  <a:srgbClr val="223038"/>
+                </a:solidFill>
+                <a:latin typeface="Calibri"/>
+              </a:rPr>
+              <a:t>Use the review app on the 143 interactions: confirm, reject, or flag for revision.</a:t>
+            </a:r>
+          </a:p>
+        </p:txBody>
+      </p:sp>
+      <p:sp>
+        <p:nvSpPr>
+          <p:cNvPr id="18" name="TextBox 17"/>
+          <p:cNvSpPr txBox="1"/>
+          <p:nvPr/>
+        </p:nvSpPr>
+        <p:spPr>
+          <a:xfrm>
+            <a:off x="548640" y="6437376"/>
+            <a:ext cx="8229600" cy="365760"/>
+          </a:xfrm>
+          <a:prstGeom prst="rect">
+            <a:avLst/>
+          </a:prstGeom>
+          <a:noFill/>
+        </p:spPr>
+        <p:txBody>
+          <a:bodyPr wrap="square">
+            <a:spAutoFit/>
+          </a:bodyPr>
+          <a:lstStyle/>
+          <a:p>
+            <a:pPr algn="l">
+              <a:spcBef>
+                <a:spcPts val="0"/>
+              </a:spcBef>
+              <a:spcAft>
+                <a:spcPts val="600"/>
+              </a:spcAft>
+            </a:pPr>
+            <a:r>
+              <a:rPr sz="900" b="0" i="0">
+                <a:solidFill>
+                  <a:srgbClr val="6B7A82"/>
+                </a:solidFill>
+                <a:latin typeface="Calibri"/>
+              </a:rPr>
+              <a:t>SSc-MIM · Molecular Interaction Map of skin fibrosis in dcSSc</a:t>
+            </a:r>
+          </a:p>
+        </p:txBody>
+      </p:sp>
+      <p:sp>
+        <p:nvSpPr>
+          <p:cNvPr id="19" name="TextBox 18"/>
+          <p:cNvSpPr txBox="1"/>
+          <p:nvPr/>
+        </p:nvSpPr>
+        <p:spPr>
+          <a:xfrm>
+            <a:off x="11247120" y="6437376"/>
+            <a:ext cx="731520" cy="365760"/>
+          </a:xfrm>
+          <a:prstGeom prst="rect">
+            <a:avLst/>
+          </a:prstGeom>
+          <a:noFill/>
+        </p:spPr>
+        <p:txBody>
+          <a:bodyPr wrap="square">
+            <a:spAutoFit/>
+          </a:bodyPr>
+          <a:lstStyle/>
+          <a:p>
+            <a:pPr algn="r">
+              <a:spcBef>
+                <a:spcPts val="0"/>
+              </a:spcBef>
+              <a:spcAft>
+                <a:spcPts val="600"/>
+              </a:spcAft>
+            </a:pPr>
+            <a:r>
+              <a:rPr sz="1000" b="0" i="0">
+                <a:solidFill>
+                  <a:srgbClr val="6B7A82"/>
+                </a:solidFill>
+                <a:latin typeface="Calibri"/>
+              </a:rPr>
+              <a:t>17</a:t>
+            </a:r>
+          </a:p>
+        </p:txBody>
+      </p:sp>
+    </p:spTree>
+  </p:cSld>
+  <p:clrMapOvr>
+    <a:masterClrMapping/>
+  </p:clrMapOvr>
+</p:sld>
+</file>
+
+<file path=ppt/slides/slide18.xml><?xml version="1.0" encoding="utf-8"?>
 <p:sld xmlns:a="http://schemas.openxmlformats.org/drawingml/2006/main" xmlns:p="http://schemas.openxmlformats.org/presentationml/2006/main" xmlns:r="http://schemas.openxmlformats.org/officeDocument/2006/relationships">
   <p:cSld>
     <p:spTree>

</xml_diff>